<commit_message>
FIX: fix generator pres ai fefu
</commit_message>
<xml_diff>
--- a/backend/app/assets/dvfu_template.pptx
+++ b/backend/app/assets/dvfu_template.pptx
@@ -42,23 +42,27 @@
       <p:boldItalic r:id="rId25"/>
     </p:embeddedFont>
     <p:embeddedFont>
+      <p:font typeface="Montserrat Medium" panose="00000600000000000000" pitchFamily="2" charset="0"/>
+      <p:regular r:id="rId26"/>
+    </p:embeddedFont>
+    <p:embeddedFont>
       <p:font typeface="Raleway" pitchFamily="2" charset="0"/>
-      <p:regular r:id="rId26"/>
-      <p:bold r:id="rId27"/>
-      <p:italic r:id="rId28"/>
-      <p:boldItalic r:id="rId29"/>
+      <p:regular r:id="rId27"/>
+      <p:bold r:id="rId28"/>
+      <p:italic r:id="rId29"/>
+      <p:boldItalic r:id="rId30"/>
     </p:embeddedFont>
     <p:embeddedFont>
       <p:font typeface="Roboto" panose="02000000000000000000" pitchFamily="2" charset="0"/>
-      <p:regular r:id="rId30"/>
-      <p:bold r:id="rId31"/>
-      <p:italic r:id="rId32"/>
-      <p:boldItalic r:id="rId33"/>
+      <p:regular r:id="rId31"/>
+      <p:bold r:id="rId32"/>
+      <p:italic r:id="rId33"/>
+      <p:boldItalic r:id="rId34"/>
     </p:embeddedFont>
     <p:embeddedFont>
       <p:font typeface="Roboto Light" panose="02000000000000000000" pitchFamily="2" charset="0"/>
-      <p:regular r:id="rId34"/>
-      <p:italic r:id="rId35"/>
+      <p:regular r:id="rId35"/>
+      <p:italic r:id="rId36"/>
     </p:embeddedFont>
   </p:embeddedFontLst>
   <p:defaultTextStyle>
@@ -22718,19 +22722,7 @@
                 <a:cs typeface="Montserrat"/>
                 <a:sym typeface="Montserrat"/>
               </a:rPr>
-              <a:t>Введите </a:t>
-            </a:r>
-            <a:r>
-              <a:rPr lang="ru" sz="1000" dirty="0">
-                <a:solidFill>
-                  <a:srgbClr val="1F497D"/>
-                </a:solidFill>
-                <a:latin typeface="+mj-lt"/>
-                <a:ea typeface="Montserrat"/>
-                <a:cs typeface="Montserrat"/>
-                <a:sym typeface="Montserrat"/>
-              </a:rPr>
-              <a:t>текст</a:t>
+              <a:t>Текст 1</a:t>
             </a:r>
             <a:endParaRPr sz="1000" b="0" i="0" u="none" strike="noStrike" cap="none" dirty="0">
               <a:solidFill>
@@ -22808,19 +22800,7 @@
                 <a:cs typeface="Montserrat"/>
                 <a:sym typeface="Montserrat"/>
               </a:rPr>
-              <a:t>Введите </a:t>
-            </a:r>
-            <a:r>
-              <a:rPr lang="ru" sz="1000" dirty="0">
-                <a:solidFill>
-                  <a:srgbClr val="1F497D"/>
-                </a:solidFill>
-                <a:latin typeface="+mj-lt"/>
-                <a:ea typeface="Montserrat"/>
-                <a:cs typeface="Montserrat"/>
-                <a:sym typeface="Montserrat"/>
-              </a:rPr>
-              <a:t>текст</a:t>
+              <a:t>Текст 2</a:t>
             </a:r>
             <a:endParaRPr sz="1000" b="0" i="0" u="none" strike="noStrike" cap="none" dirty="0">
               <a:solidFill>
@@ -22976,19 +22956,7 @@
                 <a:cs typeface="Montserrat"/>
                 <a:sym typeface="Montserrat"/>
               </a:rPr>
-              <a:t>Введите </a:t>
-            </a:r>
-            <a:r>
-              <a:rPr lang="ru" sz="1000" dirty="0">
-                <a:solidFill>
-                  <a:srgbClr val="1F497D"/>
-                </a:solidFill>
-                <a:latin typeface="+mj-lt"/>
-                <a:ea typeface="Montserrat"/>
-                <a:cs typeface="Montserrat"/>
-                <a:sym typeface="Montserrat"/>
-              </a:rPr>
-              <a:t>текст</a:t>
+              <a:t>Текст 3</a:t>
             </a:r>
             <a:endParaRPr sz="1000" b="0" i="0" u="none" strike="noStrike" cap="none" dirty="0">
               <a:solidFill>
@@ -23141,34 +23109,19 @@
           </a:bodyPr>
           <a:lstStyle/>
           <a:p>
-            <a:pPr marL="0" marR="0" lvl="0" indent="0" algn="l" rtl="0">
-              <a:lnSpc>
-                <a:spcPct val="100000"/>
-              </a:lnSpc>
-              <a:spcBef>
-                <a:spcPts val="0"/>
-              </a:spcBef>
-              <a:spcAft>
-                <a:spcPts val="0"/>
-              </a:spcAft>
-              <a:buClr>
-                <a:srgbClr val="000000"/>
-              </a:buClr>
+            <a:pPr lvl="0">
               <a:buSzPts val="1900"/>
-              <a:buFont typeface="Arial"/>
-              <a:buNone/>
             </a:pPr>
             <a:r>
-              <a:rPr lang="ru" sz="2000" b="1" i="0" u="none" strike="noStrike" cap="none" dirty="0">
-                <a:solidFill>
-                  <a:schemeClr val="dk1"/>
-                </a:solidFill>
-                <a:latin typeface="+mj-lt"/>
+              <a:rPr lang="ru" sz="2000" b="1" dirty="0">
+                <a:solidFill>
+                  <a:schemeClr val="dk1"/>
+                </a:solidFill>
                 <a:ea typeface="Montserrat Medium"/>
                 <a:cs typeface="Montserrat Medium"/>
                 <a:sym typeface="Montserrat Medium"/>
               </a:rPr>
-              <a:t>ЗАГОЛОВОК ОСНОВНАЯ МЫСЛЬ</a:t>
+              <a:t>ЗАГОЛОВОК</a:t>
             </a:r>
             <a:endParaRPr sz="2000" b="1" i="0" u="none" strike="noStrike" cap="none" dirty="0">
               <a:solidFill>
@@ -23734,34 +23687,19 @@
           </a:bodyPr>
           <a:lstStyle/>
           <a:p>
-            <a:pPr marL="0" marR="0" lvl="0" indent="0" algn="l" rtl="0">
-              <a:lnSpc>
-                <a:spcPct val="100000"/>
-              </a:lnSpc>
-              <a:spcBef>
-                <a:spcPts val="0"/>
-              </a:spcBef>
-              <a:spcAft>
-                <a:spcPts val="0"/>
-              </a:spcAft>
-              <a:buClr>
-                <a:srgbClr val="000000"/>
-              </a:buClr>
+            <a:pPr lvl="0">
               <a:buSzPts val="1900"/>
-              <a:buFont typeface="Arial"/>
-              <a:buNone/>
             </a:pPr>
             <a:r>
-              <a:rPr lang="ru" sz="2000" b="1" i="0" u="none" strike="noStrike" cap="none" dirty="0">
-                <a:solidFill>
-                  <a:schemeClr val="dk1"/>
-                </a:solidFill>
-                <a:latin typeface="+mj-lt"/>
+              <a:rPr lang="ru" sz="2000" b="1" dirty="0">
+                <a:solidFill>
+                  <a:schemeClr val="dk1"/>
+                </a:solidFill>
                 <a:ea typeface="Montserrat Medium"/>
                 <a:cs typeface="Montserrat Medium"/>
                 <a:sym typeface="Montserrat Medium"/>
               </a:rPr>
-              <a:t>ЗАГОЛОВОК ОСНОВНАЯ МЫСЛЬ</a:t>
+              <a:t>ЗАГОЛОВОК</a:t>
             </a:r>
             <a:endParaRPr sz="2000" b="1" i="0" u="none" strike="noStrike" cap="none" dirty="0">
               <a:solidFill>
@@ -23839,19 +23777,7 @@
                 <a:cs typeface="Montserrat"/>
                 <a:sym typeface="Montserrat"/>
               </a:rPr>
-              <a:t>Введите </a:t>
-            </a:r>
-            <a:r>
-              <a:rPr lang="ru" sz="1000" dirty="0">
-                <a:solidFill>
-                  <a:srgbClr val="1F497D"/>
-                </a:solidFill>
-                <a:latin typeface="+mj-lt"/>
-                <a:ea typeface="Montserrat"/>
-                <a:cs typeface="Montserrat"/>
-                <a:sym typeface="Montserrat"/>
-              </a:rPr>
-              <a:t>текст</a:t>
+              <a:t>Текст 1</a:t>
             </a:r>
             <a:endParaRPr sz="1000" b="0" i="0" u="none" strike="noStrike" cap="none" dirty="0">
               <a:solidFill>
@@ -23929,19 +23855,7 @@
                 <a:cs typeface="Montserrat"/>
                 <a:sym typeface="Montserrat"/>
               </a:rPr>
-              <a:t>Введите </a:t>
-            </a:r>
-            <a:r>
-              <a:rPr lang="ru" sz="1000" dirty="0">
-                <a:solidFill>
-                  <a:srgbClr val="1F497D"/>
-                </a:solidFill>
-                <a:latin typeface="+mj-lt"/>
-                <a:ea typeface="Montserrat"/>
-                <a:cs typeface="Montserrat"/>
-                <a:sym typeface="Montserrat"/>
-              </a:rPr>
-              <a:t>текст</a:t>
+              <a:t>Текст 2</a:t>
             </a:r>
             <a:endParaRPr sz="1000" b="0" i="0" u="none" strike="noStrike" cap="none" dirty="0">
               <a:solidFill>
@@ -24019,19 +23933,7 @@
                 <a:cs typeface="Montserrat"/>
                 <a:sym typeface="Montserrat"/>
               </a:rPr>
-              <a:t>Введите </a:t>
-            </a:r>
-            <a:r>
-              <a:rPr lang="ru" sz="1000" dirty="0">
-                <a:solidFill>
-                  <a:srgbClr val="1F497D"/>
-                </a:solidFill>
-                <a:latin typeface="+mj-lt"/>
-                <a:ea typeface="Montserrat"/>
-                <a:cs typeface="Montserrat"/>
-                <a:sym typeface="Montserrat"/>
-              </a:rPr>
-              <a:t>текст</a:t>
+              <a:t>Результат</a:t>
             </a:r>
             <a:endParaRPr sz="1000" b="0" i="0" u="none" strike="noStrike" cap="none" dirty="0">
               <a:solidFill>
@@ -24582,34 +24484,19 @@
           </a:bodyPr>
           <a:lstStyle/>
           <a:p>
-            <a:pPr marL="0" marR="0" lvl="0" indent="0" algn="l" rtl="0">
-              <a:lnSpc>
-                <a:spcPct val="100000"/>
-              </a:lnSpc>
-              <a:spcBef>
-                <a:spcPts val="0"/>
-              </a:spcBef>
-              <a:spcAft>
-                <a:spcPts val="0"/>
-              </a:spcAft>
-              <a:buClr>
-                <a:srgbClr val="000000"/>
-              </a:buClr>
+            <a:pPr lvl="0">
               <a:buSzPts val="1900"/>
-              <a:buFont typeface="Arial"/>
-              <a:buNone/>
             </a:pPr>
             <a:r>
-              <a:rPr lang="ru" sz="2000" b="1" i="0" u="none" strike="noStrike" cap="none" dirty="0">
-                <a:solidFill>
-                  <a:schemeClr val="dk1"/>
-                </a:solidFill>
-                <a:latin typeface="+mj-lt"/>
+              <a:rPr lang="ru" sz="2000" b="1" dirty="0">
+                <a:solidFill>
+                  <a:schemeClr val="dk1"/>
+                </a:solidFill>
                 <a:ea typeface="Montserrat Medium"/>
                 <a:cs typeface="Montserrat Medium"/>
                 <a:sym typeface="Montserrat Medium"/>
               </a:rPr>
-              <a:t>ЗАГОЛОВОК ОСНОВНАЯ МЫСЛЬ</a:t>
+              <a:t>ЗАГОЛОВОК</a:t>
             </a:r>
             <a:endParaRPr sz="2000" b="1" i="0" u="none" strike="noStrike" cap="none" dirty="0">
               <a:solidFill>
@@ -24867,19 +24754,7 @@
                 <a:cs typeface="Montserrat"/>
                 <a:sym typeface="Montserrat"/>
               </a:rPr>
-              <a:t>Введите </a:t>
-            </a:r>
-            <a:r>
-              <a:rPr lang="ru" sz="1000" dirty="0">
-                <a:solidFill>
-                  <a:srgbClr val="1F497D"/>
-                </a:solidFill>
-                <a:latin typeface="+mj-lt"/>
-                <a:ea typeface="Montserrat"/>
-                <a:cs typeface="Montserrat"/>
-                <a:sym typeface="Montserrat"/>
-              </a:rPr>
-              <a:t>текст</a:t>
+              <a:t>Текст 1</a:t>
             </a:r>
             <a:endParaRPr sz="1000" b="0" i="0" u="none" strike="noStrike" cap="none" dirty="0">
               <a:solidFill>
@@ -24957,29 +24832,8 @@
                 <a:cs typeface="Montserrat"/>
                 <a:sym typeface="Montserrat"/>
               </a:rPr>
-              <a:t>Введите </a:t>
+              <a:t>Текст 2</a:t>
             </a:r>
-            <a:r>
-              <a:rPr lang="ru-RU" sz="1000" dirty="0">
-                <a:solidFill>
-                  <a:srgbClr val="1F497D"/>
-                </a:solidFill>
-                <a:latin typeface="+mj-lt"/>
-                <a:ea typeface="Montserrat"/>
-                <a:cs typeface="Montserrat"/>
-                <a:sym typeface="Montserrat"/>
-              </a:rPr>
-              <a:t>текст</a:t>
-            </a:r>
-            <a:endParaRPr lang="ru-RU" sz="1000" b="0" i="0" u="none" strike="noStrike" cap="none" dirty="0">
-              <a:solidFill>
-                <a:srgbClr val="1F497D"/>
-              </a:solidFill>
-              <a:latin typeface="+mj-lt"/>
-              <a:ea typeface="Montserrat"/>
-              <a:cs typeface="Montserrat"/>
-              <a:sym typeface="Montserrat"/>
-            </a:endParaRPr>
           </a:p>
         </p:txBody>
       </p:sp>
@@ -25047,29 +24901,8 @@
                 <a:cs typeface="Montserrat"/>
                 <a:sym typeface="Montserrat"/>
               </a:rPr>
-              <a:t>Введите </a:t>
+              <a:t>Текст 3</a:t>
             </a:r>
-            <a:r>
-              <a:rPr lang="ru-RU" sz="1000" dirty="0">
-                <a:solidFill>
-                  <a:srgbClr val="1F497D"/>
-                </a:solidFill>
-                <a:latin typeface="+mj-lt"/>
-                <a:ea typeface="Montserrat"/>
-                <a:cs typeface="Montserrat"/>
-                <a:sym typeface="Montserrat"/>
-              </a:rPr>
-              <a:t>текст</a:t>
-            </a:r>
-            <a:endParaRPr lang="ru-RU" sz="1000" b="0" i="0" u="none" strike="noStrike" cap="none" dirty="0">
-              <a:solidFill>
-                <a:srgbClr val="1F497D"/>
-              </a:solidFill>
-              <a:latin typeface="+mj-lt"/>
-              <a:ea typeface="Montserrat"/>
-              <a:cs typeface="Montserrat"/>
-              <a:sym typeface="Montserrat"/>
-            </a:endParaRPr>
           </a:p>
         </p:txBody>
       </p:sp>
@@ -25137,29 +24970,8 @@
                 <a:cs typeface="Montserrat"/>
                 <a:sym typeface="Montserrat"/>
               </a:rPr>
-              <a:t>Введите </a:t>
+              <a:t>Текст 4</a:t>
             </a:r>
-            <a:r>
-              <a:rPr lang="ru-RU" sz="1000" dirty="0">
-                <a:solidFill>
-                  <a:srgbClr val="1F497D"/>
-                </a:solidFill>
-                <a:latin typeface="+mj-lt"/>
-                <a:ea typeface="Montserrat"/>
-                <a:cs typeface="Montserrat"/>
-                <a:sym typeface="Montserrat"/>
-              </a:rPr>
-              <a:t>текст</a:t>
-            </a:r>
-            <a:endParaRPr lang="ru-RU" sz="1000" b="0" i="0" u="none" strike="noStrike" cap="none" dirty="0">
-              <a:solidFill>
-                <a:srgbClr val="1F497D"/>
-              </a:solidFill>
-              <a:latin typeface="+mj-lt"/>
-              <a:ea typeface="Montserrat"/>
-              <a:cs typeface="Montserrat"/>
-              <a:sym typeface="Montserrat"/>
-            </a:endParaRPr>
           </a:p>
         </p:txBody>
       </p:sp>
@@ -25716,7 +25528,7 @@
                 <a:cs typeface="Montserrat"/>
                 <a:sym typeface="Montserrat"/>
               </a:rPr>
-              <a:t>ПОДЗАГОЛОВОК</a:t>
+              <a:t>Слово 1</a:t>
             </a:r>
             <a:endParaRPr sz="1000" b="1" dirty="0">
               <a:solidFill>
@@ -25841,7 +25653,7 @@
                 <a:cs typeface="Montserrat"/>
                 <a:sym typeface="Montserrat"/>
               </a:rPr>
-              <a:t>ПОДЗАГОЛОВОК</a:t>
+              <a:t>Слово 2</a:t>
             </a:r>
           </a:p>
         </p:txBody>
@@ -26327,7 +26139,7 @@
                 <a:cs typeface="Montserrat"/>
                 <a:sym typeface="Montserrat"/>
               </a:rPr>
-              <a:t>ТЕКСТ</a:t>
+              <a:t>Текст 1</a:t>
             </a:r>
             <a:endParaRPr sz="1000" b="1" dirty="0">
               <a:solidFill>
@@ -26394,7 +26206,7 @@
                 <a:cs typeface="Montserrat"/>
                 <a:sym typeface="Montserrat"/>
               </a:rPr>
-              <a:t>ТЕКСТ</a:t>
+              <a:t>Текст 2</a:t>
             </a:r>
             <a:endParaRPr sz="1000" b="1" dirty="0">
               <a:solidFill>
@@ -26461,7 +26273,7 @@
                 <a:cs typeface="Montserrat"/>
                 <a:sym typeface="Montserrat"/>
               </a:rPr>
-              <a:t>ПОДЗАГОЛОВОК</a:t>
+              <a:t>Слово 3</a:t>
             </a:r>
           </a:p>
         </p:txBody>
@@ -26767,7 +26579,7 @@
                 <a:cs typeface="Montserrat"/>
                 <a:sym typeface="Montserrat"/>
               </a:rPr>
-              <a:t>ТЕКСТ</a:t>
+              <a:t>Текст 3</a:t>
             </a:r>
             <a:endParaRPr sz="1000" b="1" dirty="0">
               <a:solidFill>
@@ -27537,8 +27349,8 @@
         </p:nvSpPr>
         <p:spPr>
           <a:xfrm>
-            <a:off x="404657" y="5017619"/>
-            <a:ext cx="2032725" cy="323135"/>
+            <a:off x="404658" y="5017619"/>
+            <a:ext cx="1600750" cy="323135"/>
           </a:xfrm>
           <a:prstGeom prst="rect">
             <a:avLst/>
@@ -27581,7 +27393,7 @@
                 <a:cs typeface="Montserrat"/>
                 <a:sym typeface="Montserrat"/>
               </a:rPr>
-              <a:t>ТЕКСТ</a:t>
+              <a:t>ТЕКСТ 1</a:t>
             </a:r>
             <a:endParaRPr lang="ru-RU" sz="900" b="0" i="0" u="none" strike="noStrike" cap="none" dirty="0">
               <a:solidFill>
@@ -27898,8 +27710,8 @@
         </p:nvSpPr>
         <p:spPr>
           <a:xfrm>
-            <a:off x="293158" y="1306461"/>
-            <a:ext cx="965076" cy="768014"/>
+            <a:off x="293157" y="1306461"/>
+            <a:ext cx="2280579" cy="768014"/>
           </a:xfrm>
           <a:prstGeom prst="rect">
             <a:avLst/>
@@ -27933,7 +27745,7 @@
               <a:buNone/>
             </a:pPr>
             <a:r>
-              <a:rPr lang="ru" sz="1600" b="1" i="0" u="none" strike="noStrike" cap="none" dirty="0">
+              <a:rPr lang="ru-RU" sz="1600" b="1" i="0" u="none" strike="noStrike" cap="none" dirty="0">
                 <a:solidFill>
                   <a:srgbClr val="3C90DC"/>
                 </a:solidFill>
@@ -27942,7 +27754,19 @@
                 <a:cs typeface="Montserrat"/>
                 <a:sym typeface="Montserrat"/>
               </a:rPr>
-              <a:t>ГОД</a:t>
+              <a:t>С</a:t>
+            </a:r>
+            <a:r>
+              <a:rPr lang="ru" sz="1600" b="1" i="0" u="none" strike="noStrike" cap="none" dirty="0">
+                <a:solidFill>
+                  <a:srgbClr val="3C90DC"/>
+                </a:solidFill>
+                <a:latin typeface="+mj-lt"/>
+                <a:ea typeface="Montserrat"/>
+                <a:cs typeface="Montserrat"/>
+                <a:sym typeface="Montserrat"/>
+              </a:rPr>
+              <a:t>лово 1</a:t>
             </a:r>
             <a:endParaRPr sz="1600" b="1" i="0" u="none" strike="noStrike" cap="none" dirty="0">
               <a:solidFill>
@@ -27971,7 +27795,7 @@
         <p:spPr>
           <a:xfrm>
             <a:off x="6636410" y="1306461"/>
-            <a:ext cx="965076" cy="768014"/>
+            <a:ext cx="1543010" cy="768014"/>
           </a:xfrm>
           <a:prstGeom prst="rect">
             <a:avLst/>
@@ -28005,7 +27829,7 @@
               <a:buNone/>
             </a:pPr>
             <a:r>
-              <a:rPr lang="ru" sz="1600" b="1" dirty="0">
+              <a:rPr lang="ru-RU" sz="1600" b="1" dirty="0">
                 <a:solidFill>
                   <a:srgbClr val="3C90DC"/>
                 </a:solidFill>
@@ -28014,7 +27838,19 @@
                 <a:cs typeface="Montserrat"/>
                 <a:sym typeface="Montserrat"/>
               </a:rPr>
-              <a:t>ГОД</a:t>
+              <a:t>С</a:t>
+            </a:r>
+            <a:r>
+              <a:rPr lang="ru" sz="1600" b="1" dirty="0">
+                <a:solidFill>
+                  <a:srgbClr val="3C90DC"/>
+                </a:solidFill>
+                <a:latin typeface="+mj-lt"/>
+                <a:ea typeface="Montserrat"/>
+                <a:cs typeface="Montserrat"/>
+                <a:sym typeface="Montserrat"/>
+              </a:rPr>
+              <a:t>лово 2</a:t>
             </a:r>
             <a:endParaRPr sz="1600" b="1" i="0" u="none" strike="noStrike" cap="none" dirty="0">
               <a:solidFill>
@@ -28043,7 +27879,7 @@
         <p:spPr>
           <a:xfrm>
             <a:off x="1258234" y="2571699"/>
-            <a:ext cx="2032725" cy="323135"/>
+            <a:ext cx="1897561" cy="323135"/>
           </a:xfrm>
           <a:prstGeom prst="rect">
             <a:avLst/>
@@ -28086,7 +27922,7 @@
                 <a:cs typeface="Montserrat"/>
                 <a:sym typeface="Montserrat"/>
               </a:rPr>
-              <a:t>ТЕКСТ</a:t>
+              <a:t>ТЕКСТ 2</a:t>
             </a:r>
             <a:endParaRPr lang="ru-RU" sz="900" b="0" i="0" u="none" strike="noStrike" cap="none" dirty="0">
               <a:solidFill>
@@ -28158,7 +27994,7 @@
                 <a:cs typeface="Montserrat"/>
                 <a:sym typeface="Montserrat"/>
               </a:rPr>
-              <a:t>ТЕКСТ</a:t>
+              <a:t>ТЕКСТ 3</a:t>
             </a:r>
             <a:endParaRPr lang="ru-RU" sz="900" b="0" i="0" u="none" strike="noStrike" cap="none" dirty="0">
               <a:solidFill>
@@ -28230,7 +28066,7 @@
                 <a:cs typeface="Montserrat"/>
                 <a:sym typeface="Montserrat"/>
               </a:rPr>
-              <a:t>ТЕКСТ</a:t>
+              <a:t>ТЕКСТ 5</a:t>
             </a:r>
             <a:endParaRPr lang="ru-RU" sz="900" b="0" i="0" u="none" strike="noStrike" cap="none" dirty="0">
               <a:solidFill>
@@ -28302,7 +28138,7 @@
                 <a:cs typeface="Montserrat"/>
                 <a:sym typeface="Montserrat"/>
               </a:rPr>
-              <a:t>ТЕКСТ</a:t>
+              <a:t>ТЕКСТ 4</a:t>
             </a:r>
             <a:endParaRPr lang="ru-RU" sz="900" b="0" i="0" u="none" strike="noStrike" cap="none" dirty="0">
               <a:solidFill>
@@ -28374,17 +28210,8 @@
                 <a:cs typeface="Montserrat"/>
                 <a:sym typeface="Montserrat"/>
               </a:rPr>
-              <a:t>ТЕКСТ</a:t>
+              <a:t>ТЕКСТ 6</a:t>
             </a:r>
-            <a:endParaRPr lang="ru-RU" sz="900" b="0" i="0" u="none" strike="noStrike" cap="none" dirty="0">
-              <a:solidFill>
-                <a:schemeClr val="dk1"/>
-              </a:solidFill>
-              <a:latin typeface="+mj-lt"/>
-              <a:ea typeface="Montserrat"/>
-              <a:cs typeface="Montserrat"/>
-              <a:sym typeface="Montserrat"/>
-            </a:endParaRPr>
           </a:p>
         </p:txBody>
       </p:sp>
@@ -28446,7 +28273,7 @@
                 <a:cs typeface="Montserrat"/>
                 <a:sym typeface="Montserrat"/>
               </a:rPr>
-              <a:t>ТЕКСТ</a:t>
+              <a:t>ТЕКСТ 7</a:t>
             </a:r>
             <a:endParaRPr lang="ru-RU" sz="900" b="0" i="0" u="none" strike="noStrike" cap="none" dirty="0">
               <a:solidFill>
@@ -28981,7 +28808,7 @@
         <p:spPr>
           <a:xfrm>
             <a:off x="275576" y="214114"/>
-            <a:ext cx="5744648" cy="738633"/>
+            <a:ext cx="5744648" cy="492412"/>
           </a:xfrm>
           <a:prstGeom prst="rect">
             <a:avLst/>
@@ -29010,58 +28837,6 @@
               <a:buClr>
                 <a:srgbClr val="000000"/>
               </a:buClr>
-              <a:buSzPts val="1400"/>
-              <a:buFont typeface="Arial"/>
-              <a:buNone/>
-            </a:pPr>
-            <a:r>
-              <a:rPr lang="ru-RU" sz="1600" i="0" u="none" strike="noStrike" cap="none" dirty="0">
-                <a:solidFill>
-                  <a:schemeClr val="dk1"/>
-                </a:solidFill>
-                <a:latin typeface="+mj-lt"/>
-                <a:ea typeface="Montserrat Light"/>
-                <a:cs typeface="Montserrat Light"/>
-                <a:sym typeface="Montserrat Light"/>
-              </a:rPr>
-              <a:t>ЗАГОЛОВОК</a:t>
-            </a:r>
-            <a:r>
-              <a:rPr lang="ru-RU" sz="1600" b="1" i="0" u="none" strike="noStrike" cap="none" dirty="0">
-                <a:solidFill>
-                  <a:schemeClr val="dk1"/>
-                </a:solidFill>
-                <a:latin typeface="+mj-lt"/>
-                <a:ea typeface="Montserrat Light"/>
-                <a:cs typeface="Montserrat Light"/>
-                <a:sym typeface="Montserrat Light"/>
-              </a:rPr>
-              <a:t> </a:t>
-            </a:r>
-            <a:endParaRPr sz="1600" b="1" i="0" u="none" strike="noStrike" cap="none" dirty="0">
-              <a:solidFill>
-                <a:schemeClr val="dk1"/>
-              </a:solidFill>
-              <a:latin typeface="+mj-lt"/>
-              <a:ea typeface="Montserrat Light"/>
-              <a:cs typeface="Montserrat Light"/>
-              <a:sym typeface="Montserrat Light"/>
-            </a:endParaRPr>
-          </a:p>
-          <a:p>
-            <a:pPr marL="0" marR="0" lvl="0" indent="0" algn="l" rtl="0">
-              <a:lnSpc>
-                <a:spcPct val="100000"/>
-              </a:lnSpc>
-              <a:spcBef>
-                <a:spcPts val="0"/>
-              </a:spcBef>
-              <a:spcAft>
-                <a:spcPts val="0"/>
-              </a:spcAft>
-              <a:buClr>
-                <a:srgbClr val="000000"/>
-              </a:buClr>
               <a:buSzPts val="1900"/>
               <a:buFont typeface="Arial"/>
               <a:buNone/>
@@ -29076,7 +28851,19 @@
                 <a:cs typeface="Montserrat Medium"/>
                 <a:sym typeface="Montserrat Medium"/>
               </a:rPr>
-              <a:t>ЗАГОЛОВОК ОСНОВНАЯ МЫСЛЬ</a:t>
+              <a:t>ЗАГОЛОВО</a:t>
+            </a:r>
+            <a:r>
+              <a:rPr lang="ru" sz="2000" b="1" dirty="0">
+                <a:solidFill>
+                  <a:schemeClr val="dk1"/>
+                </a:solidFill>
+                <a:latin typeface="+mj-lt"/>
+                <a:ea typeface="Montserrat Medium"/>
+                <a:cs typeface="Montserrat Medium"/>
+                <a:sym typeface="Montserrat Medium"/>
+              </a:rPr>
+              <a:t>К</a:t>
             </a:r>
             <a:endParaRPr sz="2000" b="1" i="0" u="none" strike="noStrike" cap="none" dirty="0">
               <a:solidFill>
@@ -30660,7 +30447,7 @@
                 <a:cs typeface="Montserrat"/>
                 <a:sym typeface="Montserrat"/>
               </a:rPr>
-              <a:t>Этап 5</a:t>
+              <a:t>Слово 5</a:t>
             </a:r>
             <a:endParaRPr lang="ru-RU" sz="1800" dirty="0"/>
           </a:p>
@@ -30773,7 +30560,7 @@
               <a:buNone/>
             </a:pPr>
             <a:r>
-              <a:rPr lang="ru" sz="1000" dirty="0">
+              <a:rPr lang="ru-RU" sz="1000" dirty="0">
                 <a:solidFill>
                   <a:schemeClr val="dk1"/>
                 </a:solidFill>
@@ -30782,7 +30569,19 @@
                 <a:cs typeface="Montserrat"/>
                 <a:sym typeface="Montserrat"/>
               </a:rPr>
-              <a:t>Этап 1</a:t>
+              <a:t>С</a:t>
+            </a:r>
+            <a:r>
+              <a:rPr lang="ru" sz="1000" dirty="0">
+                <a:solidFill>
+                  <a:schemeClr val="dk1"/>
+                </a:solidFill>
+                <a:latin typeface="Montserrat"/>
+                <a:ea typeface="Montserrat"/>
+                <a:cs typeface="Montserrat"/>
+                <a:sym typeface="Montserrat"/>
+              </a:rPr>
+              <a:t>лово 1</a:t>
             </a:r>
             <a:endParaRPr sz="1800" dirty="0"/>
           </a:p>
@@ -30846,7 +30645,7 @@
                 <a:cs typeface="Montserrat"/>
                 <a:sym typeface="Montserrat"/>
               </a:rPr>
-              <a:t>Этап 2</a:t>
+              <a:t>Слово 2</a:t>
             </a:r>
             <a:endParaRPr lang="ru-RU" sz="1800" dirty="0"/>
           </a:p>
@@ -30910,7 +30709,7 @@
                 <a:cs typeface="Montserrat"/>
                 <a:sym typeface="Montserrat"/>
               </a:rPr>
-              <a:t>Этап 3</a:t>
+              <a:t>Слово 3</a:t>
             </a:r>
             <a:endParaRPr lang="ru-RU" sz="1800" dirty="0"/>
           </a:p>
@@ -30974,7 +30773,7 @@
                 <a:cs typeface="Montserrat"/>
                 <a:sym typeface="Montserrat"/>
               </a:rPr>
-              <a:t>Этап 4</a:t>
+              <a:t>Слово  4</a:t>
             </a:r>
             <a:endParaRPr lang="ru-RU" sz="1800" dirty="0"/>
           </a:p>
@@ -31301,34 +31100,19 @@
           </a:bodyPr>
           <a:lstStyle/>
           <a:p>
-            <a:pPr marL="0" marR="0" lvl="0" indent="0" algn="l" rtl="0">
-              <a:lnSpc>
-                <a:spcPct val="100000"/>
-              </a:lnSpc>
-              <a:spcBef>
-                <a:spcPts val="0"/>
-              </a:spcBef>
-              <a:spcAft>
-                <a:spcPts val="0"/>
-              </a:spcAft>
-              <a:buClr>
-                <a:srgbClr val="000000"/>
-              </a:buClr>
+            <a:pPr lvl="0">
               <a:buSzPts val="1900"/>
-              <a:buFont typeface="Arial"/>
-              <a:buNone/>
             </a:pPr>
             <a:r>
-              <a:rPr lang="ru" sz="2000" b="1" i="0" u="none" strike="noStrike" cap="none" dirty="0">
-                <a:solidFill>
-                  <a:schemeClr val="dk1"/>
-                </a:solidFill>
-                <a:latin typeface="+mj-lt"/>
+              <a:rPr lang="ru" sz="2000" b="1" dirty="0">
+                <a:solidFill>
+                  <a:schemeClr val="dk1"/>
+                </a:solidFill>
                 <a:ea typeface="Montserrat Medium"/>
                 <a:cs typeface="Montserrat Medium"/>
                 <a:sym typeface="Montserrat Medium"/>
               </a:rPr>
-              <a:t>ЗАГОЛОВОК ОСНОВНАЯ МЫСЛЬ</a:t>
+              <a:t>ЗАГОЛОВОК</a:t>
             </a:r>
             <a:endParaRPr sz="2000" b="1" i="0" u="none" strike="noStrike" cap="none" dirty="0">
               <a:solidFill>
@@ -31374,12 +31158,12 @@
           </a:ln>
         </p:spPr>
         <p:txBody>
-          <a:bodyPr spcFirstLastPara="1" wrap="square" lIns="68575" tIns="68575" rIns="68575" bIns="68575" anchor="ctr" anchorCtr="0">
+          <a:bodyPr spcFirstLastPara="1" wrap="square" lIns="68575" tIns="68575" rIns="68575" bIns="68575" anchor="t" anchorCtr="0">
             <a:noAutofit/>
           </a:bodyPr>
           <a:lstStyle/>
           <a:p>
-            <a:pPr marL="0" marR="0" lvl="0" indent="0" algn="ctr" rtl="0">
+            <a:pPr marL="0" marR="0" lvl="0" indent="0" rtl="0">
               <a:lnSpc>
                 <a:spcPct val="100000"/>
               </a:lnSpc>
@@ -31406,19 +31190,7 @@
                 <a:cs typeface="Montserrat"/>
                 <a:sym typeface="Montserrat"/>
               </a:rPr>
-              <a:t>Введите </a:t>
-            </a:r>
-            <a:r>
-              <a:rPr lang="ru" sz="1000" dirty="0">
-                <a:solidFill>
-                  <a:srgbClr val="1F497D"/>
-                </a:solidFill>
-                <a:latin typeface="+mj-lt"/>
-                <a:ea typeface="Montserrat"/>
-                <a:cs typeface="Montserrat"/>
-                <a:sym typeface="Montserrat"/>
-              </a:rPr>
-              <a:t>текст</a:t>
+              <a:t>Текст 1</a:t>
             </a:r>
             <a:endParaRPr sz="1000" b="0" i="0" u="none" strike="noStrike" cap="none" dirty="0">
               <a:solidFill>
@@ -31464,61 +31236,25 @@
           </a:ln>
         </p:spPr>
         <p:txBody>
-          <a:bodyPr spcFirstLastPara="1" wrap="square" lIns="68575" tIns="68575" rIns="68575" bIns="68575" anchor="ctr" anchorCtr="0">
+          <a:bodyPr spcFirstLastPara="1" wrap="square" lIns="68575" tIns="68575" rIns="68575" bIns="68575" anchor="t" anchorCtr="0">
             <a:noAutofit/>
           </a:bodyPr>
           <a:lstStyle/>
           <a:p>
-            <a:pPr marL="0" marR="0" lvl="0" indent="0" algn="ctr" rtl="0">
-              <a:lnSpc>
-                <a:spcPct val="100000"/>
-              </a:lnSpc>
-              <a:spcBef>
-                <a:spcPts val="0"/>
-              </a:spcBef>
-              <a:spcAft>
-                <a:spcPts val="0"/>
-              </a:spcAft>
-              <a:buClr>
-                <a:srgbClr val="000000"/>
-              </a:buClr>
+            <a:pPr lvl="0">
               <a:buSzPts val="900"/>
-              <a:buFont typeface="Arial"/>
-              <a:buNone/>
             </a:pPr>
             <a:r>
-              <a:rPr lang="ru" sz="1000" b="0" i="0" u="none" strike="noStrike" cap="none" dirty="0">
+              <a:rPr lang="ru-RU" sz="1000" dirty="0">
                 <a:solidFill>
                   <a:srgbClr val="1F497D"/>
                 </a:solidFill>
-                <a:latin typeface="+mj-lt"/>
                 <a:ea typeface="Montserrat"/>
                 <a:cs typeface="Montserrat"/>
                 <a:sym typeface="Montserrat"/>
               </a:rPr>
-              <a:t>Введите </a:t>
+              <a:t>Текст 2</a:t>
             </a:r>
-            <a:r>
-              <a:rPr lang="ru" sz="1000" dirty="0">
-                <a:solidFill>
-                  <a:srgbClr val="1F497D"/>
-                </a:solidFill>
-                <a:latin typeface="+mj-lt"/>
-                <a:ea typeface="Montserrat"/>
-                <a:cs typeface="Montserrat"/>
-                <a:sym typeface="Montserrat"/>
-              </a:rPr>
-              <a:t>текст</a:t>
-            </a:r>
-            <a:endParaRPr sz="1000" b="0" i="0" u="none" strike="noStrike" cap="none" dirty="0">
-              <a:solidFill>
-                <a:srgbClr val="1F497D"/>
-              </a:solidFill>
-              <a:latin typeface="+mj-lt"/>
-              <a:ea typeface="Montserrat"/>
-              <a:cs typeface="Montserrat"/>
-              <a:sym typeface="Montserrat"/>
-            </a:endParaRPr>
           </a:p>
         </p:txBody>
       </p:sp>
@@ -31554,12 +31290,12 @@
           </a:ln>
         </p:spPr>
         <p:txBody>
-          <a:bodyPr spcFirstLastPara="1" wrap="square" lIns="68575" tIns="68575" rIns="68575" bIns="68575" anchor="ctr" anchorCtr="0">
+          <a:bodyPr spcFirstLastPara="1" wrap="square" lIns="68575" tIns="68575" rIns="68575" bIns="68575" anchor="t" anchorCtr="0">
             <a:noAutofit/>
           </a:bodyPr>
           <a:lstStyle/>
           <a:p>
-            <a:pPr marL="0" marR="0" lvl="0" indent="0" algn="ctr" rtl="0">
+            <a:pPr marL="0" marR="0" lvl="0" indent="0" rtl="0">
               <a:lnSpc>
                 <a:spcPct val="100000"/>
               </a:lnSpc>
@@ -31586,19 +31322,7 @@
                 <a:cs typeface="Montserrat"/>
                 <a:sym typeface="Montserrat"/>
               </a:rPr>
-              <a:t>Введите </a:t>
-            </a:r>
-            <a:r>
-              <a:rPr lang="ru" sz="1000" dirty="0">
-                <a:solidFill>
-                  <a:srgbClr val="1F497D"/>
-                </a:solidFill>
-                <a:latin typeface="+mj-lt"/>
-                <a:ea typeface="Montserrat"/>
-                <a:cs typeface="Montserrat"/>
-                <a:sym typeface="Montserrat"/>
-              </a:rPr>
-              <a:t>текст</a:t>
+              <a:t>Текст 4</a:t>
             </a:r>
             <a:endParaRPr sz="1000" b="0" i="0" u="none" strike="noStrike" cap="none" dirty="0">
               <a:solidFill>
@@ -31644,12 +31368,12 @@
           </a:ln>
         </p:spPr>
         <p:txBody>
-          <a:bodyPr spcFirstLastPara="1" wrap="square" lIns="68575" tIns="68575" rIns="68575" bIns="68575" anchor="ctr" anchorCtr="0">
+          <a:bodyPr spcFirstLastPara="1" wrap="square" lIns="68575" tIns="68575" rIns="68575" bIns="68575" anchor="t" anchorCtr="0">
             <a:noAutofit/>
           </a:bodyPr>
           <a:lstStyle/>
           <a:p>
-            <a:pPr marL="0" marR="0" lvl="0" indent="0" algn="ctr" rtl="0">
+            <a:pPr marL="0" marR="0" lvl="0" indent="0" rtl="0">
               <a:lnSpc>
                 <a:spcPct val="100000"/>
               </a:lnSpc>
@@ -31676,21 +31400,9 @@
                 <a:cs typeface="Montserrat"/>
                 <a:sym typeface="Montserrat"/>
               </a:rPr>
-              <a:t>Введите </a:t>
+              <a:t>Текст 3</a:t>
             </a:r>
-            <a:r>
-              <a:rPr lang="ru" sz="1000" dirty="0">
-                <a:solidFill>
-                  <a:srgbClr val="1F497D"/>
-                </a:solidFill>
-                <a:latin typeface="+mj-lt"/>
-                <a:ea typeface="Montserrat"/>
-                <a:cs typeface="Montserrat"/>
-                <a:sym typeface="Montserrat"/>
-              </a:rPr>
-              <a:t>текст</a:t>
-            </a:r>
-            <a:endParaRPr sz="1000" b="0" i="0" u="none" strike="noStrike" cap="none" dirty="0">
+            <a:endParaRPr lang="ru" sz="1000" dirty="0">
               <a:solidFill>
                 <a:srgbClr val="1F497D"/>
               </a:solidFill>
@@ -31734,12 +31446,12 @@
           </a:ln>
         </p:spPr>
         <p:txBody>
-          <a:bodyPr spcFirstLastPara="1" wrap="square" lIns="68575" tIns="68575" rIns="68575" bIns="68575" anchor="ctr" anchorCtr="0">
+          <a:bodyPr spcFirstLastPara="1" wrap="square" lIns="68575" tIns="68575" rIns="68575" bIns="68575" anchor="t" anchorCtr="0">
             <a:noAutofit/>
           </a:bodyPr>
           <a:lstStyle/>
           <a:p>
-            <a:pPr marL="0" marR="0" lvl="0" indent="0" algn="ctr" rtl="0">
+            <a:pPr marL="0" marR="0" lvl="0" indent="0" rtl="0">
               <a:lnSpc>
                 <a:spcPct val="100000"/>
               </a:lnSpc>
@@ -31766,19 +31478,7 @@
                 <a:cs typeface="Montserrat"/>
                 <a:sym typeface="Montserrat"/>
               </a:rPr>
-              <a:t>Введите </a:t>
-            </a:r>
-            <a:r>
-              <a:rPr lang="ru" sz="1000" dirty="0">
-                <a:solidFill>
-                  <a:srgbClr val="1F497D"/>
-                </a:solidFill>
-                <a:latin typeface="+mj-lt"/>
-                <a:ea typeface="Montserrat"/>
-                <a:cs typeface="Montserrat"/>
-                <a:sym typeface="Montserrat"/>
-              </a:rPr>
-              <a:t>текст</a:t>
+              <a:t>Текст 5</a:t>
             </a:r>
             <a:endParaRPr sz="1000" b="0" i="0" u="none" strike="noStrike" cap="none" dirty="0">
               <a:solidFill>
@@ -32312,7 +32012,7 @@
         </p:nvSpPr>
         <p:spPr>
           <a:xfrm>
-            <a:off x="1275493" y="2630049"/>
+            <a:off x="1274686" y="2873803"/>
             <a:ext cx="2566191" cy="1646444"/>
           </a:xfrm>
           <a:prstGeom prst="rect">
@@ -32339,7 +32039,7 @@
                 <a:cs typeface="Montserrat"/>
                 <a:sym typeface="Montserrat"/>
               </a:rPr>
-              <a:t>Введите текст</a:t>
+              <a:t>Текст 1</a:t>
             </a:r>
             <a:endParaRPr sz="1200" b="0" i="0" u="none" strike="noStrike" cap="none" dirty="0">
               <a:solidFill>
@@ -32401,7 +32101,7 @@
         </p:nvSpPr>
         <p:spPr>
           <a:xfrm>
-            <a:off x="4203537" y="2609657"/>
+            <a:off x="4202730" y="2853411"/>
             <a:ext cx="2386144" cy="703173"/>
           </a:xfrm>
           <a:prstGeom prst="rect">
@@ -32428,7 +32128,7 @@
                 <a:cs typeface="Montserrat"/>
                 <a:sym typeface="Montserrat"/>
               </a:rPr>
-              <a:t>Введите текст</a:t>
+              <a:t>Текст 2</a:t>
             </a:r>
           </a:p>
           <a:p>
@@ -32470,7 +32170,7 @@
         </p:nvSpPr>
         <p:spPr>
           <a:xfrm>
-            <a:off x="6875136" y="2609657"/>
+            <a:off x="6874329" y="2853411"/>
             <a:ext cx="2287232" cy="703173"/>
           </a:xfrm>
           <a:prstGeom prst="rect">
@@ -32497,7 +32197,7 @@
                 <a:cs typeface="Montserrat"/>
                 <a:sym typeface="Montserrat"/>
               </a:rPr>
-              <a:t>Введите текст</a:t>
+              <a:t>Текст 3</a:t>
             </a:r>
           </a:p>
           <a:p>
@@ -32540,7 +32240,7 @@
         <p:spPr>
           <a:xfrm>
             <a:off x="1274686" y="1993767"/>
-            <a:ext cx="713121" cy="585978"/>
+            <a:ext cx="2566191" cy="585978"/>
           </a:xfrm>
           <a:prstGeom prst="rect">
             <a:avLst/>
@@ -32607,7 +32307,7 @@
         <p:spPr>
           <a:xfrm>
             <a:off x="4203764" y="1993766"/>
-            <a:ext cx="713121" cy="585978"/>
+            <a:ext cx="2423920" cy="585978"/>
           </a:xfrm>
           <a:prstGeom prst="rect">
             <a:avLst/>
@@ -32674,7 +32374,7 @@
         <p:spPr>
           <a:xfrm>
             <a:off x="6908143" y="1993766"/>
-            <a:ext cx="713121" cy="585978"/>
+            <a:ext cx="2423920" cy="585978"/>
           </a:xfrm>
           <a:prstGeom prst="rect">
             <a:avLst/>
@@ -32703,7 +32403,7 @@
               <a:buNone/>
             </a:pPr>
             <a:r>
-              <a:rPr lang="ru" sz="3600" b="1" i="0" u="none" strike="noStrike" cap="none">
+              <a:rPr lang="ru" sz="3600" b="1" i="0" u="none" strike="noStrike" cap="none" dirty="0">
                 <a:solidFill>
                   <a:srgbClr val="3C90DC"/>
                 </a:solidFill>
@@ -32714,7 +32414,7 @@
               </a:rPr>
               <a:t>3</a:t>
             </a:r>
-            <a:endParaRPr sz="3600" b="1" i="0" u="none" strike="noStrike" cap="none">
+            <a:endParaRPr sz="3600" b="1" i="0" u="none" strike="noStrike" cap="none" dirty="0">
               <a:solidFill>
                 <a:srgbClr val="3C90DC"/>
               </a:solidFill>
@@ -32740,7 +32440,7 @@
         </p:nvSpPr>
         <p:spPr>
           <a:xfrm>
-            <a:off x="9624425" y="2609657"/>
+            <a:off x="9623618" y="2853411"/>
             <a:ext cx="2279504" cy="703173"/>
           </a:xfrm>
           <a:prstGeom prst="rect">
@@ -32767,7 +32467,7 @@
                 <a:cs typeface="Montserrat"/>
                 <a:sym typeface="Montserrat"/>
               </a:rPr>
-              <a:t>Введите текст</a:t>
+              <a:t>Текст 4</a:t>
             </a:r>
           </a:p>
           <a:p>
@@ -32810,7 +32510,7 @@
         <p:spPr>
           <a:xfrm>
             <a:off x="9657431" y="1993766"/>
-            <a:ext cx="713121" cy="585978"/>
+            <a:ext cx="2347709" cy="585978"/>
           </a:xfrm>
           <a:prstGeom prst="rect">
             <a:avLst/>
@@ -32839,7 +32539,7 @@
               <a:buNone/>
             </a:pPr>
             <a:r>
-              <a:rPr lang="ru" sz="3600" b="1" i="0" u="none" strike="noStrike" cap="none">
+              <a:rPr lang="ru" sz="3600" b="1" i="0" u="none" strike="noStrike" cap="none" dirty="0">
                 <a:solidFill>
                   <a:srgbClr val="3C90DC"/>
                 </a:solidFill>
@@ -32850,7 +32550,7 @@
               </a:rPr>
               <a:t>4</a:t>
             </a:r>
-            <a:endParaRPr sz="3600" b="1" i="0" u="none" strike="noStrike" cap="none">
+            <a:endParaRPr sz="3600" b="1" i="0" u="none" strike="noStrike" cap="none" dirty="0">
               <a:solidFill>
                 <a:srgbClr val="3C90DC"/>
               </a:solidFill>
@@ -32988,7 +32688,7 @@
                 <a:cs typeface="Montserrat Medium"/>
                 <a:sym typeface="Montserrat Medium"/>
               </a:rPr>
-              <a:t>ЗАГОЛОВОК ОСНОВНАЯ МЫСЛЬ</a:t>
+              <a:t>ЗАГОЛОВОК</a:t>
             </a:r>
             <a:endParaRPr sz="2000" b="1" i="0" u="none" strike="noStrike" cap="none" dirty="0">
               <a:solidFill>
@@ -33445,34 +33145,19 @@
           </a:bodyPr>
           <a:lstStyle/>
           <a:p>
-            <a:pPr marL="0" marR="0" lvl="0" indent="0" algn="l" rtl="0">
-              <a:lnSpc>
-                <a:spcPct val="100000"/>
-              </a:lnSpc>
-              <a:spcBef>
-                <a:spcPts val="0"/>
-              </a:spcBef>
-              <a:spcAft>
-                <a:spcPts val="0"/>
-              </a:spcAft>
-              <a:buClr>
-                <a:srgbClr val="000000"/>
-              </a:buClr>
+            <a:pPr lvl="0">
               <a:buSzPts val="1900"/>
-              <a:buFont typeface="Arial"/>
-              <a:buNone/>
             </a:pPr>
             <a:r>
-              <a:rPr lang="ru" sz="2000" b="1" i="0" u="none" strike="noStrike" cap="none" dirty="0">
-                <a:solidFill>
-                  <a:schemeClr val="dk1"/>
-                </a:solidFill>
-                <a:latin typeface="+mj-lt"/>
+              <a:rPr lang="ru" sz="2000" b="1" dirty="0">
+                <a:solidFill>
+                  <a:schemeClr val="dk1"/>
+                </a:solidFill>
                 <a:ea typeface="Montserrat Medium"/>
                 <a:cs typeface="Montserrat Medium"/>
                 <a:sym typeface="Montserrat Medium"/>
               </a:rPr>
-              <a:t>ЗАГОЛОВОК ОСНОВНАЯ МЫСЛЬ</a:t>
+              <a:t>ЗАГОЛОВОК</a:t>
             </a:r>
             <a:endParaRPr sz="2000" b="1" i="0" u="none" strike="noStrike" cap="none" dirty="0">
               <a:solidFill>
@@ -33499,14 +33184,14 @@
           <p:nvPr>
             <p:extLst>
               <p:ext uri="{D42A27DB-BD31-4B8C-83A1-F6EECF244321}">
-                <p14:modId xmlns:p14="http://schemas.microsoft.com/office/powerpoint/2010/main" val="3998358999"/>
+                <p14:modId xmlns:p14="http://schemas.microsoft.com/office/powerpoint/2010/main" val="3014758487"/>
               </p:ext>
             </p:extLst>
           </p:nvPr>
         </p:nvGraphicFramePr>
         <p:xfrm>
           <a:off x="396241" y="1092413"/>
-          <a:ext cx="11440160" cy="4918096"/>
+          <a:ext cx="11613623" cy="4918096"/>
         </p:xfrm>
         <a:graphic>
           <a:graphicData uri="http://schemas.openxmlformats.org/drawingml/2006/table">
@@ -33515,35 +33200,28 @@
                 <a:noFill/>
               </a:tblPr>
               <a:tblGrid>
-                <a:gridCol w="662465">
+                <a:gridCol w="778917">
                   <a:extLst>
                     <a:ext uri="{9D8B030D-6E8A-4147-A177-3AD203B41FA5}">
                       <a16:colId xmlns:a16="http://schemas.microsoft.com/office/drawing/2014/main" val="20000"/>
                     </a:ext>
                   </a:extLst>
                 </a:gridCol>
-                <a:gridCol w="6584456">
+                <a:gridCol w="7741906">
                   <a:extLst>
                     <a:ext uri="{9D8B030D-6E8A-4147-A177-3AD203B41FA5}">
                       <a16:colId xmlns:a16="http://schemas.microsoft.com/office/drawing/2014/main" val="20001"/>
                     </a:ext>
                   </a:extLst>
                 </a:gridCol>
-                <a:gridCol w="1562827">
-                  <a:extLst>
-                    <a:ext uri="{9D8B030D-6E8A-4147-A177-3AD203B41FA5}">
-                      <a16:colId xmlns:a16="http://schemas.microsoft.com/office/drawing/2014/main" val="20002"/>
-                    </a:ext>
-                  </a:extLst>
-                </a:gridCol>
-                <a:gridCol w="1595413">
+                <a:gridCol w="1875863">
                   <a:extLst>
                     <a:ext uri="{9D8B030D-6E8A-4147-A177-3AD203B41FA5}">
                       <a16:colId xmlns:a16="http://schemas.microsoft.com/office/drawing/2014/main" val="20003"/>
                     </a:ext>
                   </a:extLst>
                 </a:gridCol>
-                <a:gridCol w="1034999">
+                <a:gridCol w="1216937">
                   <a:extLst>
                     <a:ext uri="{9D8B030D-6E8A-4147-A177-3AD203B41FA5}">
                       <a16:colId xmlns:a16="http://schemas.microsoft.com/office/drawing/2014/main" val="20004"/>
@@ -33675,98 +33353,7 @@
                           <a:cs typeface="Roboto"/>
                           <a:sym typeface="Roboto"/>
                         </a:rPr>
-                        <a:t>НАИМЕНОВАНИЕ ПОКАЗАТЕЛЯ</a:t>
-                      </a:r>
-                      <a:endParaRPr sz="1050" b="1" i="0" u="none" strike="noStrike" cap="none" dirty="0">
-                        <a:solidFill>
-                          <a:srgbClr val="000000"/>
-                        </a:solidFill>
-                        <a:latin typeface="Roboto"/>
-                        <a:ea typeface="Roboto"/>
-                        <a:cs typeface="Roboto"/>
-                        <a:sym typeface="Roboto"/>
-                      </a:endParaRPr>
-                    </a:p>
-                  </a:txBody>
-                  <a:tcPr marL="54775" marR="54775" marT="0" marB="0" anchor="ctr">
-                    <a:lnL w="9525" cap="flat" cmpd="sng">
-                      <a:solidFill>
-                        <a:srgbClr val="000000">
-                          <a:alpha val="0"/>
-                        </a:srgbClr>
-                      </a:solidFill>
-                      <a:prstDash val="solid"/>
-                      <a:round/>
-                      <a:headEnd type="none" w="sm" len="sm"/>
-                      <a:tailEnd type="none" w="sm" len="sm"/>
-                    </a:lnL>
-                    <a:lnR w="9525" cap="flat" cmpd="sng">
-                      <a:solidFill>
-                        <a:srgbClr val="000000">
-                          <a:alpha val="0"/>
-                        </a:srgbClr>
-                      </a:solidFill>
-                      <a:prstDash val="solid"/>
-                      <a:round/>
-                      <a:headEnd type="none" w="sm" len="sm"/>
-                      <a:tailEnd type="none" w="sm" len="sm"/>
-                    </a:lnR>
-                    <a:lnT w="9525" cap="flat" cmpd="sng">
-                      <a:solidFill>
-                        <a:srgbClr val="000000">
-                          <a:alpha val="0"/>
-                        </a:srgbClr>
-                      </a:solidFill>
-                      <a:prstDash val="solid"/>
-                      <a:round/>
-                      <a:headEnd type="none" w="sm" len="sm"/>
-                      <a:tailEnd type="none" w="sm" len="sm"/>
-                    </a:lnT>
-                    <a:lnB w="9525" cap="flat" cmpd="sng">
-                      <a:noFill/>
-                      <a:prstDash val="solid"/>
-                      <a:round/>
-                      <a:headEnd type="none" w="sm" len="sm"/>
-                      <a:tailEnd type="none" w="sm" len="sm"/>
-                    </a:lnB>
-                    <a:solidFill>
-                      <a:schemeClr val="lt1"/>
-                    </a:solidFill>
-                  </a:tcPr>
-                </a:tc>
-                <a:tc>
-                  <a:txBody>
-                    <a:bodyPr/>
-                    <a:lstStyle/>
-                    <a:p>
-                      <a:pPr marL="0" marR="0" lvl="0" indent="0" algn="ctr" rtl="0">
-                        <a:lnSpc>
-                          <a:spcPct val="107916"/>
-                        </a:lnSpc>
-                        <a:spcBef>
-                          <a:spcPts val="0"/>
-                        </a:spcBef>
-                        <a:spcAft>
-                          <a:spcPts val="0"/>
-                        </a:spcAft>
-                        <a:buClr>
-                          <a:srgbClr val="000000"/>
-                        </a:buClr>
-                        <a:buSzPts val="800"/>
-                        <a:buFont typeface="Arial"/>
-                        <a:buNone/>
-                      </a:pPr>
-                      <a:r>
-                        <a:rPr lang="ru" sz="1050" b="1" i="0" u="none" strike="noStrike" cap="none" dirty="0">
-                          <a:solidFill>
-                            <a:srgbClr val="000000"/>
-                          </a:solidFill>
-                          <a:latin typeface="Roboto"/>
-                          <a:ea typeface="Roboto"/>
-                          <a:cs typeface="Roboto"/>
-                          <a:sym typeface="Roboto"/>
-                        </a:rPr>
-                        <a:t>ЕД. ИЗМЕРЕНИЯ</a:t>
+                        <a:t>Показатель</a:t>
                       </a:r>
                       <a:endParaRPr sz="1050" b="1" i="0" u="none" strike="noStrike" cap="none" dirty="0">
                         <a:solidFill>
@@ -33857,7 +33444,7 @@
                           <a:cs typeface="Roboto"/>
                           <a:sym typeface="Roboto"/>
                         </a:rPr>
-                        <a:t>ДАТА</a:t>
+                        <a:t>Слово</a:t>
                       </a:r>
                       <a:endParaRPr sz="1050" b="1" dirty="0">
                         <a:latin typeface="Roboto"/>
@@ -33868,7 +33455,7 @@
                     </a:p>
                   </a:txBody>
                   <a:tcPr marL="54775" marR="54775" marT="0" marB="0" anchor="ctr">
-                    <a:lnL w="9525" cap="flat" cmpd="sng">
+                    <a:lnL w="9525" cap="flat" cmpd="sng" algn="ctr">
                       <a:solidFill>
                         <a:srgbClr val="000000">
                           <a:alpha val="0"/>
@@ -33945,7 +33532,7 @@
                           <a:cs typeface="Roboto"/>
                           <a:sym typeface="Roboto"/>
                         </a:rPr>
-                        <a:t>ДАТА</a:t>
+                        <a:t>Слово</a:t>
                       </a:r>
                       <a:endParaRPr sz="1050" b="1" dirty="0">
                         <a:solidFill>
@@ -34210,7 +33797,7 @@
                         <a:buNone/>
                       </a:pPr>
                       <a:r>
-                        <a:rPr lang="ru" sz="1050" b="0" i="0" u="none" strike="noStrike" cap="none" dirty="0">
+                        <a:rPr lang="ru-RU" sz="1400" b="0" i="0" u="none" strike="noStrike" cap="none" dirty="0">
                           <a:solidFill>
                             <a:srgbClr val="000000"/>
                           </a:solidFill>
@@ -34219,94 +33806,7 @@
                           <a:cs typeface="Roboto"/>
                           <a:sym typeface="Roboto"/>
                         </a:rPr>
-                        <a:t>единица</a:t>
-                      </a:r>
-                      <a:endParaRPr sz="1050" b="0" i="0" u="none" strike="noStrike" cap="none" dirty="0">
-                        <a:solidFill>
-                          <a:srgbClr val="000000"/>
-                        </a:solidFill>
-                        <a:latin typeface="Roboto"/>
-                        <a:ea typeface="Roboto"/>
-                        <a:cs typeface="Roboto"/>
-                        <a:sym typeface="Roboto"/>
-                      </a:endParaRPr>
-                    </a:p>
-                  </a:txBody>
-                  <a:tcPr marL="54775" marR="54775" marT="0" marB="0" anchor="ctr">
-                    <a:lnL w="9525" cap="flat" cmpd="sng">
-                      <a:noFill/>
-                      <a:prstDash val="solid"/>
-                      <a:round/>
-                      <a:headEnd type="none" w="sm" len="sm"/>
-                      <a:tailEnd type="none" w="sm" len="sm"/>
-                    </a:lnL>
-                    <a:lnR w="9525" cap="flat" cmpd="sng">
-                      <a:noFill/>
-                      <a:prstDash val="solid"/>
-                      <a:round/>
-                      <a:headEnd type="none" w="sm" len="sm"/>
-                      <a:tailEnd type="none" w="sm" len="sm"/>
-                    </a:lnR>
-                    <a:lnT w="9525" cap="flat" cmpd="sng">
-                      <a:noFill/>
-                      <a:prstDash val="solid"/>
-                      <a:round/>
-                      <a:headEnd type="none" w="sm" len="sm"/>
-                      <a:tailEnd type="none" w="sm" len="sm"/>
-                    </a:lnT>
-                    <a:lnB w="9525" cap="flat" cmpd="sng">
-                      <a:noFill/>
-                      <a:prstDash val="solid"/>
-                      <a:round/>
-                      <a:headEnd type="none" w="sm" len="sm"/>
-                      <a:tailEnd type="none" w="sm" len="sm"/>
-                    </a:lnB>
-                    <a:lnTlToBr w="12700" cmpd="sng">
-                      <a:noFill/>
-                      <a:prstDash val="solid"/>
-                    </a:lnTlToBr>
-                    <a:lnBlToTr w="12700" cmpd="sng">
-                      <a:noFill/>
-                      <a:prstDash val="solid"/>
-                    </a:lnBlToTr>
-                    <a:solidFill>
-                      <a:srgbClr val="E9F0F7"/>
-                    </a:solidFill>
-                  </a:tcPr>
-                </a:tc>
-                <a:tc>
-                  <a:txBody>
-                    <a:bodyPr/>
-                    <a:lstStyle/>
-                    <a:p>
-                      <a:pPr marL="0" marR="0" lvl="0" indent="0" algn="ctr" rtl="0">
-                        <a:lnSpc>
-                          <a:spcPct val="107916"/>
-                        </a:lnSpc>
-                        <a:spcBef>
-                          <a:spcPts val="0"/>
-                        </a:spcBef>
-                        <a:spcAft>
-                          <a:spcPts val="0"/>
-                        </a:spcAft>
-                        <a:buClr>
-                          <a:srgbClr val="000000"/>
-                        </a:buClr>
-                        <a:buSzPts val="800"/>
-                        <a:buFont typeface="Arial"/>
-                        <a:buNone/>
-                      </a:pPr>
-                      <a:r>
-                        <a:rPr lang="ru" sz="1400" b="0" i="0" u="none" strike="noStrike" cap="none" dirty="0">
-                          <a:solidFill>
-                            <a:srgbClr val="000000"/>
-                          </a:solidFill>
-                          <a:latin typeface="Roboto"/>
-                          <a:ea typeface="Roboto"/>
-                          <a:cs typeface="Roboto"/>
-                          <a:sym typeface="Roboto"/>
-                        </a:rPr>
-                        <a:t>0</a:t>
+                        <a:t>Число</a:t>
                       </a:r>
                       <a:endParaRPr sz="1400" b="0" i="0" u="none" strike="noStrike" cap="none" dirty="0">
                         <a:solidFill>
@@ -34384,16 +33884,16 @@
                         <a:buNone/>
                       </a:pPr>
                       <a:r>
-                        <a:rPr lang="ru" sz="1400" b="1" u="none" strike="noStrike" cap="none" dirty="0">
+                        <a:rPr lang="ru-RU" sz="1400" b="0" i="0" u="none" strike="noStrike" cap="none" dirty="0">
                           <a:solidFill>
-                            <a:srgbClr val="041A72"/>
+                            <a:srgbClr val="000000"/>
                           </a:solidFill>
                           <a:latin typeface="Roboto"/>
                           <a:ea typeface="Roboto"/>
                           <a:cs typeface="Roboto"/>
                           <a:sym typeface="Roboto"/>
                         </a:rPr>
-                        <a:t>0</a:t>
+                        <a:t>Число</a:t>
                       </a:r>
                       <a:endParaRPr sz="1400" b="1" i="0" u="none" strike="noStrike" cap="none" dirty="0">
                         <a:solidFill>
@@ -34645,103 +34145,22 @@
                         <a:buNone/>
                       </a:pPr>
                       <a:r>
-                        <a:rPr lang="ru" sz="1050" b="0" i="0" u="none" strike="noStrike" cap="none" dirty="0">
+                        <a:rPr kumimoji="0" lang="ru-RU" sz="1400" b="0" i="0" u="none" strike="noStrike" kern="0" cap="none" spc="0" normalizeH="0" baseline="0" noProof="0">
+                          <a:ln>
+                            <a:noFill/>
+                          </a:ln>
                           <a:solidFill>
                             <a:srgbClr val="000000"/>
                           </a:solidFill>
+                          <a:effectLst/>
+                          <a:uLnTx/>
+                          <a:uFillTx/>
                           <a:latin typeface="Roboto"/>
                           <a:ea typeface="Roboto"/>
                           <a:cs typeface="Roboto"/>
                           <a:sym typeface="Roboto"/>
                         </a:rPr>
-                        <a:t>единица</a:t>
-                      </a:r>
-                      <a:endParaRPr sz="1050" b="0" i="0" u="none" strike="noStrike" cap="none" dirty="0">
-                        <a:solidFill>
-                          <a:srgbClr val="000000"/>
-                        </a:solidFill>
-                        <a:latin typeface="Roboto"/>
-                        <a:ea typeface="Roboto"/>
-                        <a:cs typeface="Roboto"/>
-                        <a:sym typeface="Roboto"/>
-                      </a:endParaRPr>
-                    </a:p>
-                  </a:txBody>
-                  <a:tcPr marL="54775" marR="54775" marT="0" marB="0" anchor="ctr">
-                    <a:lnL w="9525" cap="flat" cmpd="sng">
-                      <a:noFill/>
-                      <a:prstDash val="solid"/>
-                      <a:round/>
-                      <a:headEnd type="none" w="sm" len="sm"/>
-                      <a:tailEnd type="none" w="sm" len="sm"/>
-                    </a:lnL>
-                    <a:lnR w="9525" cap="flat" cmpd="sng">
-                      <a:noFill/>
-                      <a:prstDash val="solid"/>
-                      <a:round/>
-                      <a:headEnd type="none" w="sm" len="sm"/>
-                      <a:tailEnd type="none" w="sm" len="sm"/>
-                    </a:lnR>
-                    <a:lnT w="9525" cap="flat" cmpd="sng">
-                      <a:noFill/>
-                      <a:prstDash val="solid"/>
-                      <a:round/>
-                      <a:headEnd type="none" w="sm" len="sm"/>
-                      <a:tailEnd type="none" w="sm" len="sm"/>
-                    </a:lnT>
-                    <a:lnB w="9525" cap="flat" cmpd="sng">
-                      <a:noFill/>
-                      <a:prstDash val="solid"/>
-                      <a:round/>
-                      <a:headEnd type="none" w="sm" len="sm"/>
-                      <a:tailEnd type="none" w="sm" len="sm"/>
-                    </a:lnB>
-                    <a:lnTlToBr w="12700" cmpd="sng">
-                      <a:noFill/>
-                      <a:prstDash val="solid"/>
-                    </a:lnTlToBr>
-                    <a:lnBlToTr w="12700" cmpd="sng">
-                      <a:noFill/>
-                      <a:prstDash val="solid"/>
-                    </a:lnBlToTr>
-                    <a:solidFill>
-                      <a:schemeClr val="lt1"/>
-                    </a:solidFill>
-                  </a:tcPr>
-                </a:tc>
-                <a:tc>
-                  <a:txBody>
-                    <a:bodyPr/>
-                    <a:lstStyle/>
-                    <a:p>
-                      <a:pPr marL="0" marR="0" lvl="0" indent="0" algn="ctr" rtl="0">
-                        <a:lnSpc>
-                          <a:spcPct val="107916"/>
-                        </a:lnSpc>
-                        <a:spcBef>
-                          <a:spcPts val="0"/>
-                        </a:spcBef>
-                        <a:spcAft>
-                          <a:spcPts val="0"/>
-                        </a:spcAft>
-                        <a:buClr>
-                          <a:srgbClr val="000000"/>
-                        </a:buClr>
-                        <a:buSzPts val="800"/>
-                        <a:buFont typeface="Arial"/>
-                        <a:buNone/>
-                      </a:pPr>
-                      <a:r>
-                        <a:rPr lang="ru" sz="1400" b="0" i="0" u="none" strike="noStrike" cap="none" dirty="0">
-                          <a:solidFill>
-                            <a:srgbClr val="000000"/>
-                          </a:solidFill>
-                          <a:latin typeface="Roboto"/>
-                          <a:ea typeface="Roboto"/>
-                          <a:cs typeface="Roboto"/>
-                          <a:sym typeface="Roboto"/>
-                        </a:rPr>
-                        <a:t>0</a:t>
+                        <a:t>Число</a:t>
                       </a:r>
                       <a:endParaRPr sz="1400" b="0" i="0" u="none" strike="noStrike" cap="none" dirty="0">
                         <a:solidFill>
@@ -34819,16 +34238,22 @@
                         <a:buNone/>
                       </a:pPr>
                       <a:r>
-                        <a:rPr lang="ru" sz="1400" b="1" u="none" strike="noStrike" cap="none" dirty="0">
+                        <a:rPr kumimoji="0" lang="ru-RU" sz="1400" b="0" i="0" u="none" strike="noStrike" kern="0" cap="none" spc="0" normalizeH="0" baseline="0" noProof="0">
+                          <a:ln>
+                            <a:noFill/>
+                          </a:ln>
                           <a:solidFill>
-                            <a:srgbClr val="041A72"/>
+                            <a:srgbClr val="000000"/>
                           </a:solidFill>
+                          <a:effectLst/>
+                          <a:uLnTx/>
+                          <a:uFillTx/>
                           <a:latin typeface="Roboto"/>
                           <a:ea typeface="Roboto"/>
                           <a:cs typeface="Roboto"/>
                           <a:sym typeface="Roboto"/>
                         </a:rPr>
-                        <a:t>0</a:t>
+                        <a:t>Число</a:t>
                       </a:r>
                       <a:endParaRPr sz="1400" b="1" i="0" u="none" strike="noStrike" cap="none" dirty="0">
                         <a:solidFill>
@@ -35080,100 +34505,22 @@
                         <a:buNone/>
                       </a:pPr>
                       <a:r>
-                        <a:rPr lang="ru" sz="1050" b="0" i="0" u="none" strike="noStrike" cap="none" dirty="0">
+                        <a:rPr kumimoji="0" lang="ru-RU" sz="1400" b="0" i="0" u="none" strike="noStrike" kern="0" cap="none" spc="0" normalizeH="0" baseline="0" noProof="0">
+                          <a:ln>
+                            <a:noFill/>
+                          </a:ln>
                           <a:solidFill>
                             <a:srgbClr val="000000"/>
                           </a:solidFill>
+                          <a:effectLst/>
+                          <a:uLnTx/>
+                          <a:uFillTx/>
                           <a:latin typeface="Roboto"/>
                           <a:ea typeface="Roboto"/>
                           <a:cs typeface="Roboto"/>
                           <a:sym typeface="Roboto"/>
                         </a:rPr>
-                        <a:t>тыс.руб.</a:t>
-                      </a:r>
-                      <a:endParaRPr sz="1050" b="0" i="0" u="none" strike="noStrike" cap="none" dirty="0">
-                        <a:solidFill>
-                          <a:srgbClr val="000000"/>
-                        </a:solidFill>
-                        <a:latin typeface="Roboto"/>
-                        <a:ea typeface="Roboto"/>
-                        <a:cs typeface="Roboto"/>
-                        <a:sym typeface="Roboto"/>
-                      </a:endParaRPr>
-                    </a:p>
-                  </a:txBody>
-                  <a:tcPr marL="54775" marR="54775" marT="0" marB="0" anchor="ctr">
-                    <a:lnL w="9525" cap="flat" cmpd="sng">
-                      <a:noFill/>
-                      <a:prstDash val="solid"/>
-                      <a:round/>
-                      <a:headEnd type="none" w="sm" len="sm"/>
-                      <a:tailEnd type="none" w="sm" len="sm"/>
-                    </a:lnL>
-                    <a:lnR w="9525" cap="flat" cmpd="sng">
-                      <a:noFill/>
-                      <a:prstDash val="solid"/>
-                      <a:round/>
-                      <a:headEnd type="none" w="sm" len="sm"/>
-                      <a:tailEnd type="none" w="sm" len="sm"/>
-                    </a:lnR>
-                    <a:lnT w="9525" cap="flat" cmpd="sng">
-                      <a:noFill/>
-                      <a:prstDash val="solid"/>
-                      <a:round/>
-                      <a:headEnd type="none" w="sm" len="sm"/>
-                      <a:tailEnd type="none" w="sm" len="sm"/>
-                    </a:lnT>
-                    <a:lnB w="9525" cap="flat" cmpd="sng">
-                      <a:noFill/>
-                      <a:prstDash val="solid"/>
-                      <a:round/>
-                      <a:headEnd type="none" w="sm" len="sm"/>
-                      <a:tailEnd type="none" w="sm" len="sm"/>
-                    </a:lnB>
-                    <a:lnTlToBr w="12700" cmpd="sng">
-                      <a:noFill/>
-                      <a:prstDash val="solid"/>
-                    </a:lnTlToBr>
-                    <a:lnBlToTr w="12700" cmpd="sng">
-                      <a:noFill/>
-                      <a:prstDash val="solid"/>
-                    </a:lnBlToTr>
-                    <a:solidFill>
-                      <a:srgbClr val="E9F0F7"/>
-                    </a:solidFill>
-                  </a:tcPr>
-                </a:tc>
-                <a:tc>
-                  <a:txBody>
-                    <a:bodyPr/>
-                    <a:lstStyle/>
-                    <a:p>
-                      <a:pPr marL="0" marR="0" lvl="0" indent="0" algn="ctr" rtl="0">
-                        <a:lnSpc>
-                          <a:spcPct val="107916"/>
-                        </a:lnSpc>
-                        <a:spcBef>
-                          <a:spcPts val="0"/>
-                        </a:spcBef>
-                        <a:spcAft>
-                          <a:spcPts val="0"/>
-                        </a:spcAft>
-                        <a:buClr>
-                          <a:srgbClr val="000000"/>
-                        </a:buClr>
-                        <a:buSzPts val="800"/>
-                        <a:buFont typeface="Arial"/>
-                        <a:buNone/>
-                      </a:pPr>
-                      <a:r>
-                        <a:rPr lang="ru" sz="1400" u="none" strike="noStrike" cap="none" dirty="0">
-                          <a:latin typeface="Roboto"/>
-                          <a:ea typeface="Roboto"/>
-                          <a:cs typeface="Roboto"/>
-                          <a:sym typeface="Roboto"/>
-                        </a:rPr>
-                        <a:t>0</a:t>
+                        <a:t>Число</a:t>
                       </a:r>
                       <a:endParaRPr sz="1400" b="0" i="0" u="none" strike="noStrike" cap="none" dirty="0">
                         <a:solidFill>
@@ -35251,16 +34598,22 @@
                         <a:buNone/>
                       </a:pPr>
                       <a:r>
-                        <a:rPr lang="ru" sz="1400" b="1" u="none" strike="noStrike" cap="none" dirty="0">
+                        <a:rPr kumimoji="0" lang="ru-RU" sz="1400" b="0" i="0" u="none" strike="noStrike" kern="0" cap="none" spc="0" normalizeH="0" baseline="0" noProof="0">
+                          <a:ln>
+                            <a:noFill/>
+                          </a:ln>
                           <a:solidFill>
-                            <a:srgbClr val="041A72"/>
+                            <a:srgbClr val="000000"/>
                           </a:solidFill>
+                          <a:effectLst/>
+                          <a:uLnTx/>
+                          <a:uFillTx/>
                           <a:latin typeface="Roboto"/>
                           <a:ea typeface="Roboto"/>
                           <a:cs typeface="Roboto"/>
                           <a:sym typeface="Roboto"/>
                         </a:rPr>
-                        <a:t>0</a:t>
+                        <a:t>Число</a:t>
                       </a:r>
                       <a:endParaRPr sz="1400" b="1" u="none" strike="noStrike" cap="none" dirty="0">
                         <a:solidFill>
@@ -35512,103 +34865,22 @@
                         <a:buNone/>
                       </a:pPr>
                       <a:r>
-                        <a:rPr lang="ru" sz="1050" b="0" i="0" u="none" strike="noStrike" cap="none" dirty="0">
+                        <a:rPr kumimoji="0" lang="ru-RU" sz="1400" b="0" i="0" u="none" strike="noStrike" kern="0" cap="none" spc="0" normalizeH="0" baseline="0" noProof="0">
+                          <a:ln>
+                            <a:noFill/>
+                          </a:ln>
                           <a:solidFill>
                             <a:srgbClr val="000000"/>
                           </a:solidFill>
+                          <a:effectLst/>
+                          <a:uLnTx/>
+                          <a:uFillTx/>
                           <a:latin typeface="Roboto"/>
                           <a:ea typeface="Roboto"/>
                           <a:cs typeface="Roboto"/>
                           <a:sym typeface="Roboto"/>
                         </a:rPr>
-                        <a:t>тыс.руб.</a:t>
-                      </a:r>
-                      <a:endParaRPr sz="1050" b="0" i="0" u="none" strike="noStrike" cap="none" dirty="0">
-                        <a:solidFill>
-                          <a:srgbClr val="000000"/>
-                        </a:solidFill>
-                        <a:latin typeface="Roboto"/>
-                        <a:ea typeface="Roboto"/>
-                        <a:cs typeface="Roboto"/>
-                        <a:sym typeface="Roboto"/>
-                      </a:endParaRPr>
-                    </a:p>
-                  </a:txBody>
-                  <a:tcPr marL="54775" marR="54775" marT="0" marB="0" anchor="ctr">
-                    <a:lnL w="9525" cap="flat" cmpd="sng">
-                      <a:noFill/>
-                      <a:prstDash val="solid"/>
-                      <a:round/>
-                      <a:headEnd type="none" w="sm" len="sm"/>
-                      <a:tailEnd type="none" w="sm" len="sm"/>
-                    </a:lnL>
-                    <a:lnR w="9525" cap="flat" cmpd="sng">
-                      <a:noFill/>
-                      <a:prstDash val="solid"/>
-                      <a:round/>
-                      <a:headEnd type="none" w="sm" len="sm"/>
-                      <a:tailEnd type="none" w="sm" len="sm"/>
-                    </a:lnR>
-                    <a:lnT w="9525" cap="flat" cmpd="sng">
-                      <a:noFill/>
-                      <a:prstDash val="solid"/>
-                      <a:round/>
-                      <a:headEnd type="none" w="sm" len="sm"/>
-                      <a:tailEnd type="none" w="sm" len="sm"/>
-                    </a:lnT>
-                    <a:lnB w="9525" cap="flat" cmpd="sng">
-                      <a:noFill/>
-                      <a:prstDash val="solid"/>
-                      <a:round/>
-                      <a:headEnd type="none" w="sm" len="sm"/>
-                      <a:tailEnd type="none" w="sm" len="sm"/>
-                    </a:lnB>
-                    <a:lnTlToBr w="12700" cmpd="sng">
-                      <a:noFill/>
-                      <a:prstDash val="solid"/>
-                    </a:lnTlToBr>
-                    <a:lnBlToTr w="12700" cmpd="sng">
-                      <a:noFill/>
-                      <a:prstDash val="solid"/>
-                    </a:lnBlToTr>
-                    <a:solidFill>
-                      <a:schemeClr val="lt1"/>
-                    </a:solidFill>
-                  </a:tcPr>
-                </a:tc>
-                <a:tc>
-                  <a:txBody>
-                    <a:bodyPr/>
-                    <a:lstStyle/>
-                    <a:p>
-                      <a:pPr marL="0" marR="0" lvl="0" indent="0" algn="ctr" rtl="0">
-                        <a:lnSpc>
-                          <a:spcPct val="107916"/>
-                        </a:lnSpc>
-                        <a:spcBef>
-                          <a:spcPts val="0"/>
-                        </a:spcBef>
-                        <a:spcAft>
-                          <a:spcPts val="0"/>
-                        </a:spcAft>
-                        <a:buClr>
-                          <a:srgbClr val="000000"/>
-                        </a:buClr>
-                        <a:buSzPts val="800"/>
-                        <a:buFont typeface="Arial"/>
-                        <a:buNone/>
-                      </a:pPr>
-                      <a:r>
-                        <a:rPr lang="ru" sz="1400" b="0" i="0" u="none" strike="noStrike" cap="none" dirty="0">
-                          <a:solidFill>
-                            <a:srgbClr val="000000"/>
-                          </a:solidFill>
-                          <a:latin typeface="Roboto"/>
-                          <a:ea typeface="Roboto"/>
-                          <a:cs typeface="Roboto"/>
-                          <a:sym typeface="Roboto"/>
-                        </a:rPr>
-                        <a:t>0</a:t>
+                        <a:t>Число</a:t>
                       </a:r>
                       <a:endParaRPr sz="1400" b="0" i="0" u="none" strike="noStrike" cap="none" dirty="0">
                         <a:solidFill>
@@ -35686,16 +34958,22 @@
                         <a:buNone/>
                       </a:pPr>
                       <a:r>
-                        <a:rPr lang="ru" sz="1400" b="1" u="none" strike="noStrike" cap="none" dirty="0">
+                        <a:rPr kumimoji="0" lang="ru-RU" sz="1400" b="0" i="0" u="none" strike="noStrike" kern="0" cap="none" spc="0" normalizeH="0" baseline="0" noProof="0">
+                          <a:ln>
+                            <a:noFill/>
+                          </a:ln>
                           <a:solidFill>
-                            <a:srgbClr val="041A72"/>
+                            <a:srgbClr val="000000"/>
                           </a:solidFill>
+                          <a:effectLst/>
+                          <a:uLnTx/>
+                          <a:uFillTx/>
                           <a:latin typeface="Roboto"/>
                           <a:ea typeface="Roboto"/>
                           <a:cs typeface="Roboto"/>
                           <a:sym typeface="Roboto"/>
                         </a:rPr>
-                        <a:t>0</a:t>
+                        <a:t>Число</a:t>
                       </a:r>
                       <a:endParaRPr sz="1400" b="1" i="0" u="none" strike="noStrike" cap="none" dirty="0">
                         <a:solidFill>
@@ -35953,103 +35231,22 @@
                         <a:buNone/>
                       </a:pPr>
                       <a:r>
-                        <a:rPr lang="ru" sz="1050" b="0" i="0" u="none" strike="noStrike" cap="none" dirty="0">
+                        <a:rPr kumimoji="0" lang="ru-RU" sz="1400" b="0" i="0" u="none" strike="noStrike" kern="0" cap="none" spc="0" normalizeH="0" baseline="0" noProof="0">
+                          <a:ln>
+                            <a:noFill/>
+                          </a:ln>
                           <a:solidFill>
                             <a:srgbClr val="000000"/>
                           </a:solidFill>
+                          <a:effectLst/>
+                          <a:uLnTx/>
+                          <a:uFillTx/>
                           <a:latin typeface="Roboto"/>
                           <a:ea typeface="Roboto"/>
                           <a:cs typeface="Roboto"/>
                           <a:sym typeface="Roboto"/>
                         </a:rPr>
-                        <a:t>процент</a:t>
-                      </a:r>
-                      <a:endParaRPr sz="1050" b="0" i="0" u="none" strike="noStrike" cap="none" dirty="0">
-                        <a:solidFill>
-                          <a:srgbClr val="000000"/>
-                        </a:solidFill>
-                        <a:latin typeface="Roboto"/>
-                        <a:ea typeface="Roboto"/>
-                        <a:cs typeface="Roboto"/>
-                        <a:sym typeface="Roboto"/>
-                      </a:endParaRPr>
-                    </a:p>
-                  </a:txBody>
-                  <a:tcPr marL="54775" marR="54775" marT="0" marB="0" anchor="ctr">
-                    <a:lnL w="9525" cap="flat" cmpd="sng">
-                      <a:noFill/>
-                      <a:prstDash val="solid"/>
-                      <a:round/>
-                      <a:headEnd type="none" w="sm" len="sm"/>
-                      <a:tailEnd type="none" w="sm" len="sm"/>
-                    </a:lnL>
-                    <a:lnR w="9525" cap="flat" cmpd="sng">
-                      <a:noFill/>
-                      <a:prstDash val="solid"/>
-                      <a:round/>
-                      <a:headEnd type="none" w="sm" len="sm"/>
-                      <a:tailEnd type="none" w="sm" len="sm"/>
-                    </a:lnR>
-                    <a:lnT w="9525" cap="flat" cmpd="sng">
-                      <a:noFill/>
-                      <a:prstDash val="solid"/>
-                      <a:round/>
-                      <a:headEnd type="none" w="sm" len="sm"/>
-                      <a:tailEnd type="none" w="sm" len="sm"/>
-                    </a:lnT>
-                    <a:lnB w="9525" cap="flat" cmpd="sng">
-                      <a:noFill/>
-                      <a:prstDash val="solid"/>
-                      <a:round/>
-                      <a:headEnd type="none" w="sm" len="sm"/>
-                      <a:tailEnd type="none" w="sm" len="sm"/>
-                    </a:lnB>
-                    <a:lnTlToBr w="12700" cmpd="sng">
-                      <a:noFill/>
-                      <a:prstDash val="solid"/>
-                    </a:lnTlToBr>
-                    <a:lnBlToTr w="12700" cmpd="sng">
-                      <a:noFill/>
-                      <a:prstDash val="solid"/>
-                    </a:lnBlToTr>
-                    <a:solidFill>
-                      <a:srgbClr val="E9F0F7"/>
-                    </a:solidFill>
-                  </a:tcPr>
-                </a:tc>
-                <a:tc>
-                  <a:txBody>
-                    <a:bodyPr/>
-                    <a:lstStyle/>
-                    <a:p>
-                      <a:pPr marL="0" marR="0" lvl="0" indent="0" algn="ctr" rtl="0">
-                        <a:lnSpc>
-                          <a:spcPct val="107916"/>
-                        </a:lnSpc>
-                        <a:spcBef>
-                          <a:spcPts val="0"/>
-                        </a:spcBef>
-                        <a:spcAft>
-                          <a:spcPts val="0"/>
-                        </a:spcAft>
-                        <a:buClr>
-                          <a:srgbClr val="000000"/>
-                        </a:buClr>
-                        <a:buSzPts val="800"/>
-                        <a:buFont typeface="Arial"/>
-                        <a:buNone/>
-                      </a:pPr>
-                      <a:r>
-                        <a:rPr lang="ru" sz="1400" b="0" i="0" u="none" strike="noStrike" cap="none" dirty="0">
-                          <a:solidFill>
-                            <a:srgbClr val="000000"/>
-                          </a:solidFill>
-                          <a:latin typeface="Roboto"/>
-                          <a:ea typeface="Roboto"/>
-                          <a:cs typeface="Roboto"/>
-                          <a:sym typeface="Roboto"/>
-                        </a:rPr>
-                        <a:t>0</a:t>
+                        <a:t>Число</a:t>
                       </a:r>
                       <a:endParaRPr sz="1400" b="0" i="0" u="none" strike="noStrike" cap="none" dirty="0">
                         <a:solidFill>
@@ -36127,16 +35324,22 @@
                         <a:buNone/>
                       </a:pPr>
                       <a:r>
-                        <a:rPr lang="ru" sz="1400" b="1" u="none" strike="noStrike" cap="none" dirty="0">
+                        <a:rPr kumimoji="0" lang="ru-RU" sz="1400" b="0" i="0" u="none" strike="noStrike" kern="0" cap="none" spc="0" normalizeH="0" baseline="0" noProof="0">
+                          <a:ln>
+                            <a:noFill/>
+                          </a:ln>
                           <a:solidFill>
-                            <a:srgbClr val="041A72"/>
+                            <a:srgbClr val="000000"/>
                           </a:solidFill>
+                          <a:effectLst/>
+                          <a:uLnTx/>
+                          <a:uFillTx/>
                           <a:latin typeface="Roboto"/>
                           <a:ea typeface="Roboto"/>
                           <a:cs typeface="Roboto"/>
                           <a:sym typeface="Roboto"/>
                         </a:rPr>
-                        <a:t>0</a:t>
+                        <a:t>Число</a:t>
                       </a:r>
                       <a:endParaRPr sz="1400" b="1" i="0" u="none" strike="noStrike" cap="none" dirty="0">
                         <a:solidFill>
@@ -36394,103 +35597,22 @@
                         <a:buNone/>
                       </a:pPr>
                       <a:r>
-                        <a:rPr lang="ru" sz="1050" b="0" i="0" u="none" strike="noStrike" cap="none" dirty="0">
+                        <a:rPr kumimoji="0" lang="ru-RU" sz="1400" b="0" i="0" u="none" strike="noStrike" kern="0" cap="none" spc="0" normalizeH="0" baseline="0" noProof="0">
+                          <a:ln>
+                            <a:noFill/>
+                          </a:ln>
                           <a:solidFill>
                             <a:srgbClr val="000000"/>
                           </a:solidFill>
+                          <a:effectLst/>
+                          <a:uLnTx/>
+                          <a:uFillTx/>
                           <a:latin typeface="Roboto"/>
                           <a:ea typeface="Roboto"/>
                           <a:cs typeface="Roboto"/>
                           <a:sym typeface="Roboto"/>
                         </a:rPr>
-                        <a:t>процент</a:t>
-                      </a:r>
-                      <a:endParaRPr sz="1050" b="0" i="0" u="none" strike="noStrike" cap="none" dirty="0">
-                        <a:solidFill>
-                          <a:srgbClr val="000000"/>
-                        </a:solidFill>
-                        <a:latin typeface="Roboto"/>
-                        <a:ea typeface="Roboto"/>
-                        <a:cs typeface="Roboto"/>
-                        <a:sym typeface="Roboto"/>
-                      </a:endParaRPr>
-                    </a:p>
-                  </a:txBody>
-                  <a:tcPr marL="54775" marR="54775" marT="0" marB="0" anchor="ctr">
-                    <a:lnL w="9525" cap="flat" cmpd="sng">
-                      <a:noFill/>
-                      <a:prstDash val="solid"/>
-                      <a:round/>
-                      <a:headEnd type="none" w="sm" len="sm"/>
-                      <a:tailEnd type="none" w="sm" len="sm"/>
-                    </a:lnL>
-                    <a:lnR w="9525" cap="flat" cmpd="sng">
-                      <a:noFill/>
-                      <a:prstDash val="solid"/>
-                      <a:round/>
-                      <a:headEnd type="none" w="sm" len="sm"/>
-                      <a:tailEnd type="none" w="sm" len="sm"/>
-                    </a:lnR>
-                    <a:lnT w="9525" cap="flat" cmpd="sng">
-                      <a:noFill/>
-                      <a:prstDash val="solid"/>
-                      <a:round/>
-                      <a:headEnd type="none" w="sm" len="sm"/>
-                      <a:tailEnd type="none" w="sm" len="sm"/>
-                    </a:lnT>
-                    <a:lnB w="9525" cap="flat" cmpd="sng">
-                      <a:noFill/>
-                      <a:prstDash val="solid"/>
-                      <a:round/>
-                      <a:headEnd type="none" w="sm" len="sm"/>
-                      <a:tailEnd type="none" w="sm" len="sm"/>
-                    </a:lnB>
-                    <a:lnTlToBr w="12700" cmpd="sng">
-                      <a:noFill/>
-                      <a:prstDash val="solid"/>
-                    </a:lnTlToBr>
-                    <a:lnBlToTr w="12700" cmpd="sng">
-                      <a:noFill/>
-                      <a:prstDash val="solid"/>
-                    </a:lnBlToTr>
-                    <a:solidFill>
-                      <a:schemeClr val="lt1"/>
-                    </a:solidFill>
-                  </a:tcPr>
-                </a:tc>
-                <a:tc>
-                  <a:txBody>
-                    <a:bodyPr/>
-                    <a:lstStyle/>
-                    <a:p>
-                      <a:pPr marL="0" marR="0" lvl="0" indent="0" algn="ctr" rtl="0">
-                        <a:lnSpc>
-                          <a:spcPct val="107916"/>
-                        </a:lnSpc>
-                        <a:spcBef>
-                          <a:spcPts val="0"/>
-                        </a:spcBef>
-                        <a:spcAft>
-                          <a:spcPts val="0"/>
-                        </a:spcAft>
-                        <a:buClr>
-                          <a:srgbClr val="000000"/>
-                        </a:buClr>
-                        <a:buSzPts val="800"/>
-                        <a:buFont typeface="Arial"/>
-                        <a:buNone/>
-                      </a:pPr>
-                      <a:r>
-                        <a:rPr lang="ru" sz="1400" b="0" i="0" u="none" strike="noStrike" cap="none" dirty="0">
-                          <a:solidFill>
-                            <a:srgbClr val="000000"/>
-                          </a:solidFill>
-                          <a:latin typeface="Roboto"/>
-                          <a:ea typeface="Roboto"/>
-                          <a:cs typeface="Roboto"/>
-                          <a:sym typeface="Roboto"/>
-                        </a:rPr>
-                        <a:t>0</a:t>
+                        <a:t>Число</a:t>
                       </a:r>
                       <a:endParaRPr sz="1400" b="0" i="0" u="none" strike="noStrike" cap="none" dirty="0">
                         <a:solidFill>
@@ -36568,16 +35690,22 @@
                         <a:buNone/>
                       </a:pPr>
                       <a:r>
-                        <a:rPr lang="ru" sz="1400" b="1" u="none" strike="noStrike" cap="none" dirty="0">
+                        <a:rPr kumimoji="0" lang="ru-RU" sz="1400" b="0" i="0" u="none" strike="noStrike" kern="0" cap="none" spc="0" normalizeH="0" baseline="0" noProof="0">
+                          <a:ln>
+                            <a:noFill/>
+                          </a:ln>
                           <a:solidFill>
-                            <a:srgbClr val="041A72"/>
+                            <a:srgbClr val="000000"/>
                           </a:solidFill>
+                          <a:effectLst/>
+                          <a:uLnTx/>
+                          <a:uFillTx/>
                           <a:latin typeface="Roboto"/>
                           <a:ea typeface="Roboto"/>
                           <a:cs typeface="Roboto"/>
                           <a:sym typeface="Roboto"/>
                         </a:rPr>
-                        <a:t>0</a:t>
+                        <a:t>Число</a:t>
                       </a:r>
                       <a:endParaRPr sz="1400" b="1" i="0" u="none" strike="noStrike" cap="none" dirty="0">
                         <a:solidFill>
@@ -36835,100 +35963,22 @@
                         <a:buNone/>
                       </a:pPr>
                       <a:r>
-                        <a:rPr lang="ru" sz="1050" b="0" i="0" u="none" strike="noStrike" cap="none" dirty="0">
+                        <a:rPr kumimoji="0" lang="ru-RU" sz="1400" b="0" i="0" u="none" strike="noStrike" kern="0" cap="none" spc="0" normalizeH="0" baseline="0" noProof="0">
+                          <a:ln>
+                            <a:noFill/>
+                          </a:ln>
                           <a:solidFill>
                             <a:srgbClr val="000000"/>
                           </a:solidFill>
+                          <a:effectLst/>
+                          <a:uLnTx/>
+                          <a:uFillTx/>
                           <a:latin typeface="Roboto"/>
                           <a:ea typeface="Roboto"/>
                           <a:cs typeface="Roboto"/>
                           <a:sym typeface="Roboto"/>
                         </a:rPr>
-                        <a:t>процент</a:t>
-                      </a:r>
-                      <a:endParaRPr sz="1050" b="0" i="0" u="none" strike="noStrike" cap="none" dirty="0">
-                        <a:solidFill>
-                          <a:srgbClr val="000000"/>
-                        </a:solidFill>
-                        <a:latin typeface="Roboto"/>
-                        <a:ea typeface="Roboto"/>
-                        <a:cs typeface="Roboto"/>
-                        <a:sym typeface="Roboto"/>
-                      </a:endParaRPr>
-                    </a:p>
-                  </a:txBody>
-                  <a:tcPr marL="54775" marR="54775" marT="0" marB="0" anchor="ctr">
-                    <a:lnL w="9525" cap="flat" cmpd="sng">
-                      <a:noFill/>
-                      <a:prstDash val="solid"/>
-                      <a:round/>
-                      <a:headEnd type="none" w="sm" len="sm"/>
-                      <a:tailEnd type="none" w="sm" len="sm"/>
-                    </a:lnL>
-                    <a:lnR w="9525" cap="flat" cmpd="sng">
-                      <a:noFill/>
-                      <a:prstDash val="solid"/>
-                      <a:round/>
-                      <a:headEnd type="none" w="sm" len="sm"/>
-                      <a:tailEnd type="none" w="sm" len="sm"/>
-                    </a:lnR>
-                    <a:lnT w="9525" cap="flat" cmpd="sng">
-                      <a:noFill/>
-                      <a:prstDash val="solid"/>
-                      <a:round/>
-                      <a:headEnd type="none" w="sm" len="sm"/>
-                      <a:tailEnd type="none" w="sm" len="sm"/>
-                    </a:lnT>
-                    <a:lnB w="9525" cap="flat" cmpd="sng">
-                      <a:noFill/>
-                      <a:prstDash val="solid"/>
-                      <a:round/>
-                      <a:headEnd type="none" w="sm" len="sm"/>
-                      <a:tailEnd type="none" w="sm" len="sm"/>
-                    </a:lnB>
-                    <a:lnTlToBr w="12700" cmpd="sng">
-                      <a:noFill/>
-                      <a:prstDash val="solid"/>
-                    </a:lnTlToBr>
-                    <a:lnBlToTr w="12700" cmpd="sng">
-                      <a:noFill/>
-                      <a:prstDash val="solid"/>
-                    </a:lnBlToTr>
-                    <a:solidFill>
-                      <a:srgbClr val="E9F0F7"/>
-                    </a:solidFill>
-                  </a:tcPr>
-                </a:tc>
-                <a:tc>
-                  <a:txBody>
-                    <a:bodyPr/>
-                    <a:lstStyle/>
-                    <a:p>
-                      <a:pPr marL="0" marR="0" lvl="0" indent="0" algn="ctr" rtl="0">
-                        <a:lnSpc>
-                          <a:spcPct val="107916"/>
-                        </a:lnSpc>
-                        <a:spcBef>
-                          <a:spcPts val="0"/>
-                        </a:spcBef>
-                        <a:spcAft>
-                          <a:spcPts val="0"/>
-                        </a:spcAft>
-                        <a:buClr>
-                          <a:srgbClr val="000000"/>
-                        </a:buClr>
-                        <a:buSzPts val="800"/>
-                        <a:buFont typeface="Arial"/>
-                        <a:buNone/>
-                      </a:pPr>
-                      <a:r>
-                        <a:rPr lang="ru" sz="1400" u="none" strike="noStrike" cap="none" dirty="0">
-                          <a:latin typeface="Roboto"/>
-                          <a:ea typeface="Roboto"/>
-                          <a:cs typeface="Roboto"/>
-                          <a:sym typeface="Roboto"/>
-                        </a:rPr>
-                        <a:t>0</a:t>
+                        <a:t>Число</a:t>
                       </a:r>
                       <a:endParaRPr sz="1400" b="0" i="0" u="none" strike="noStrike" cap="none" dirty="0">
                         <a:solidFill>
@@ -37006,16 +36056,22 @@
                         <a:buNone/>
                       </a:pPr>
                       <a:r>
-                        <a:rPr lang="ru" sz="1400" b="1" dirty="0">
+                        <a:rPr kumimoji="0" lang="ru-RU" sz="1400" b="0" i="0" u="none" strike="noStrike" kern="0" cap="none" spc="0" normalizeH="0" baseline="0" noProof="0">
+                          <a:ln>
+                            <a:noFill/>
+                          </a:ln>
                           <a:solidFill>
-                            <a:srgbClr val="041A72"/>
+                            <a:srgbClr val="000000"/>
                           </a:solidFill>
+                          <a:effectLst/>
+                          <a:uLnTx/>
+                          <a:uFillTx/>
                           <a:latin typeface="Roboto"/>
                           <a:ea typeface="Roboto"/>
                           <a:cs typeface="Roboto"/>
                           <a:sym typeface="Roboto"/>
                         </a:rPr>
-                        <a:t>0</a:t>
+                        <a:t>Число</a:t>
                       </a:r>
                       <a:endParaRPr sz="1400" b="1" u="none" strike="noStrike" cap="none" dirty="0">
                         <a:solidFill>
@@ -37273,103 +36329,22 @@
                         <a:buNone/>
                       </a:pPr>
                       <a:r>
-                        <a:rPr lang="ru" sz="1050" b="0" i="0" u="none" strike="noStrike" cap="none" dirty="0">
+                        <a:rPr kumimoji="0" lang="ru-RU" sz="1400" b="0" i="0" u="none" strike="noStrike" kern="0" cap="none" spc="0" normalizeH="0" baseline="0" noProof="0" dirty="0">
+                          <a:ln>
+                            <a:noFill/>
+                          </a:ln>
                           <a:solidFill>
                             <a:srgbClr val="000000"/>
                           </a:solidFill>
+                          <a:effectLst/>
+                          <a:uLnTx/>
+                          <a:uFillTx/>
                           <a:latin typeface="Roboto"/>
                           <a:ea typeface="Roboto"/>
                           <a:cs typeface="Roboto"/>
                           <a:sym typeface="Roboto"/>
                         </a:rPr>
-                        <a:t>тыс.руб.</a:t>
-                      </a:r>
-                      <a:endParaRPr sz="1050" b="0" i="0" u="none" strike="noStrike" cap="none" dirty="0">
-                        <a:solidFill>
-                          <a:srgbClr val="000000"/>
-                        </a:solidFill>
-                        <a:latin typeface="Roboto"/>
-                        <a:ea typeface="Roboto"/>
-                        <a:cs typeface="Roboto"/>
-                        <a:sym typeface="Roboto"/>
-                      </a:endParaRPr>
-                    </a:p>
-                  </a:txBody>
-                  <a:tcPr marL="54775" marR="54775" marT="0" marB="0" anchor="ctr">
-                    <a:lnL w="9525" cap="flat" cmpd="sng">
-                      <a:noFill/>
-                      <a:prstDash val="solid"/>
-                      <a:round/>
-                      <a:headEnd type="none" w="sm" len="sm"/>
-                      <a:tailEnd type="none" w="sm" len="sm"/>
-                    </a:lnL>
-                    <a:lnR w="9525" cap="flat" cmpd="sng">
-                      <a:noFill/>
-                      <a:prstDash val="solid"/>
-                      <a:round/>
-                      <a:headEnd type="none" w="sm" len="sm"/>
-                      <a:tailEnd type="none" w="sm" len="sm"/>
-                    </a:lnR>
-                    <a:lnT w="9525" cap="flat" cmpd="sng">
-                      <a:noFill/>
-                      <a:prstDash val="solid"/>
-                      <a:round/>
-                      <a:headEnd type="none" w="sm" len="sm"/>
-                      <a:tailEnd type="none" w="sm" len="sm"/>
-                    </a:lnT>
-                    <a:lnB w="9525" cap="flat" cmpd="sng">
-                      <a:noFill/>
-                      <a:prstDash val="solid"/>
-                      <a:round/>
-                      <a:headEnd type="none" w="sm" len="sm"/>
-                      <a:tailEnd type="none" w="sm" len="sm"/>
-                    </a:lnB>
-                    <a:lnTlToBr w="12700" cmpd="sng">
-                      <a:noFill/>
-                      <a:prstDash val="solid"/>
-                    </a:lnTlToBr>
-                    <a:lnBlToTr w="12700" cmpd="sng">
-                      <a:noFill/>
-                      <a:prstDash val="solid"/>
-                    </a:lnBlToTr>
-                    <a:solidFill>
-                      <a:schemeClr val="lt1"/>
-                    </a:solidFill>
-                  </a:tcPr>
-                </a:tc>
-                <a:tc>
-                  <a:txBody>
-                    <a:bodyPr/>
-                    <a:lstStyle/>
-                    <a:p>
-                      <a:pPr marL="0" marR="0" lvl="0" indent="0" algn="ctr" rtl="0">
-                        <a:lnSpc>
-                          <a:spcPct val="107916"/>
-                        </a:lnSpc>
-                        <a:spcBef>
-                          <a:spcPts val="0"/>
-                        </a:spcBef>
-                        <a:spcAft>
-                          <a:spcPts val="0"/>
-                        </a:spcAft>
-                        <a:buClr>
-                          <a:srgbClr val="000000"/>
-                        </a:buClr>
-                        <a:buSzPts val="800"/>
-                        <a:buFont typeface="Arial"/>
-                        <a:buNone/>
-                      </a:pPr>
-                      <a:r>
-                        <a:rPr lang="ru" sz="1400" b="0" i="0" u="none" strike="noStrike" cap="none" dirty="0">
-                          <a:solidFill>
-                            <a:srgbClr val="000000"/>
-                          </a:solidFill>
-                          <a:latin typeface="Roboto"/>
-                          <a:ea typeface="Roboto"/>
-                          <a:cs typeface="Roboto"/>
-                          <a:sym typeface="Roboto"/>
-                        </a:rPr>
-                        <a:t>0</a:t>
+                        <a:t>Число</a:t>
                       </a:r>
                       <a:endParaRPr sz="1400" b="0" i="0" u="none" strike="noStrike" cap="none" dirty="0">
                         <a:solidFill>
@@ -37447,16 +36422,22 @@
                         <a:buNone/>
                       </a:pPr>
                       <a:r>
-                        <a:rPr lang="ru" sz="1400" b="1" u="none" strike="noStrike" cap="none" dirty="0">
+                        <a:rPr kumimoji="0" lang="ru-RU" sz="1400" b="0" i="0" u="none" strike="noStrike" kern="0" cap="none" spc="0" normalizeH="0" baseline="0" noProof="0" dirty="0">
+                          <a:ln>
+                            <a:noFill/>
+                          </a:ln>
                           <a:solidFill>
-                            <a:srgbClr val="041A72"/>
+                            <a:srgbClr val="000000"/>
                           </a:solidFill>
+                          <a:effectLst/>
+                          <a:uLnTx/>
+                          <a:uFillTx/>
                           <a:latin typeface="Roboto"/>
                           <a:ea typeface="Roboto"/>
                           <a:cs typeface="Roboto"/>
                           <a:sym typeface="Roboto"/>
                         </a:rPr>
-                        <a:t>0</a:t>
+                        <a:t>Число</a:t>
                       </a:r>
                       <a:endParaRPr sz="1400" b="1" i="0" u="none" strike="noStrike" cap="none" dirty="0">
                         <a:solidFill>
@@ -38058,34 +37039,19 @@
           </a:bodyPr>
           <a:lstStyle/>
           <a:p>
-            <a:pPr marL="0" marR="0" lvl="0" indent="0" algn="l" rtl="0">
-              <a:lnSpc>
-                <a:spcPct val="100000"/>
-              </a:lnSpc>
-              <a:spcBef>
-                <a:spcPts val="0"/>
-              </a:spcBef>
-              <a:spcAft>
-                <a:spcPts val="0"/>
-              </a:spcAft>
-              <a:buClr>
-                <a:srgbClr val="000000"/>
-              </a:buClr>
+            <a:pPr lvl="0">
               <a:buSzPts val="1900"/>
-              <a:buFont typeface="Arial"/>
-              <a:buNone/>
             </a:pPr>
             <a:r>
-              <a:rPr lang="ru" sz="2000" b="1" i="0" u="none" strike="noStrike" cap="none" dirty="0">
-                <a:solidFill>
-                  <a:schemeClr val="dk1"/>
-                </a:solidFill>
-                <a:latin typeface="+mj-lt"/>
+              <a:rPr lang="ru" sz="2000" b="1" dirty="0">
+                <a:solidFill>
+                  <a:schemeClr val="dk1"/>
+                </a:solidFill>
                 <a:ea typeface="Montserrat Medium"/>
                 <a:cs typeface="Montserrat Medium"/>
                 <a:sym typeface="Montserrat Medium"/>
               </a:rPr>
-              <a:t>ЗАГОЛОВОК ОСНОВНАЯ МЫСЛЬ</a:t>
+              <a:t>ЗАГОЛОВОК</a:t>
             </a:r>
             <a:endParaRPr sz="2000" b="1" i="0" u="none" strike="noStrike" cap="none" dirty="0">
               <a:solidFill>
@@ -38163,19 +37129,7 @@
                 <a:cs typeface="Montserrat"/>
                 <a:sym typeface="Montserrat"/>
               </a:rPr>
-              <a:t>Введите </a:t>
-            </a:r>
-            <a:r>
-              <a:rPr lang="ru" sz="1000" dirty="0">
-                <a:solidFill>
-                  <a:srgbClr val="1F497D"/>
-                </a:solidFill>
-                <a:latin typeface="+mj-lt"/>
-                <a:ea typeface="Montserrat"/>
-                <a:cs typeface="Montserrat"/>
-                <a:sym typeface="Montserrat"/>
-              </a:rPr>
-              <a:t>текст</a:t>
+              <a:t>Текст 1</a:t>
             </a:r>
             <a:endParaRPr sz="1000" b="0" i="0" u="none" strike="noStrike" cap="none" dirty="0">
               <a:solidFill>
@@ -38469,19 +37423,7 @@
                 <a:cs typeface="Montserrat"/>
                 <a:sym typeface="Montserrat"/>
               </a:rPr>
-              <a:t>Введите </a:t>
-            </a:r>
-            <a:r>
-              <a:rPr lang="ru" sz="1000" dirty="0">
-                <a:solidFill>
-                  <a:srgbClr val="1F497D"/>
-                </a:solidFill>
-                <a:latin typeface="+mj-lt"/>
-                <a:ea typeface="Montserrat"/>
-                <a:cs typeface="Montserrat"/>
-                <a:sym typeface="Montserrat"/>
-              </a:rPr>
-              <a:t>текст</a:t>
+              <a:t>Текст 2</a:t>
             </a:r>
             <a:endParaRPr sz="1000" b="0" i="0" u="none" strike="noStrike" cap="none" dirty="0">
               <a:solidFill>
@@ -38595,19 +37537,7 @@
                 <a:cs typeface="Montserrat"/>
                 <a:sym typeface="Montserrat"/>
               </a:rPr>
-              <a:t>Введите </a:t>
-            </a:r>
-            <a:r>
-              <a:rPr lang="ru" sz="1000" dirty="0">
-                <a:solidFill>
-                  <a:srgbClr val="1F497D"/>
-                </a:solidFill>
-                <a:latin typeface="+mj-lt"/>
-                <a:ea typeface="Montserrat"/>
-                <a:cs typeface="Montserrat"/>
-                <a:sym typeface="Montserrat"/>
-              </a:rPr>
-              <a:t>текст</a:t>
+              <a:t>Текст 3</a:t>
             </a:r>
             <a:endParaRPr sz="1000" b="0" i="0" u="none" strike="noStrike" cap="none" dirty="0">
               <a:solidFill>
@@ -38685,19 +37615,7 @@
                 <a:cs typeface="Montserrat"/>
                 <a:sym typeface="Montserrat"/>
               </a:rPr>
-              <a:t>Введите </a:t>
-            </a:r>
-            <a:r>
-              <a:rPr lang="ru" sz="1000" dirty="0">
-                <a:solidFill>
-                  <a:srgbClr val="1F497D"/>
-                </a:solidFill>
-                <a:latin typeface="+mj-lt"/>
-                <a:ea typeface="Montserrat"/>
-                <a:cs typeface="Montserrat"/>
-                <a:sym typeface="Montserrat"/>
-              </a:rPr>
-              <a:t>текст</a:t>
+              <a:t>Текст 4</a:t>
             </a:r>
             <a:endParaRPr sz="1000" b="0" i="0" u="none" strike="noStrike" cap="none" dirty="0">
               <a:solidFill>
@@ -39272,7 +38190,7 @@
                 <a:cs typeface="Montserrat"/>
                 <a:sym typeface="Montserrat"/>
               </a:rPr>
-              <a:t>ПОДЗАГОЛОВОК</a:t>
+              <a:t>Слово</a:t>
             </a:r>
           </a:p>
         </p:txBody>
@@ -39645,19 +38563,7 @@
                 <a:cs typeface="Montserrat"/>
                 <a:sym typeface="Montserrat"/>
               </a:rPr>
-              <a:t>Введите </a:t>
-            </a:r>
-            <a:r>
-              <a:rPr lang="ru" sz="1000" dirty="0">
-                <a:solidFill>
-                  <a:srgbClr val="1F497D"/>
-                </a:solidFill>
-                <a:latin typeface="+mj-lt"/>
-                <a:ea typeface="Montserrat"/>
-                <a:cs typeface="Montserrat"/>
-                <a:sym typeface="Montserrat"/>
-              </a:rPr>
-              <a:t>текст</a:t>
+              <a:t>Текст 1</a:t>
             </a:r>
             <a:endParaRPr sz="1000" b="0" i="0" u="none" strike="noStrike" cap="none" dirty="0">
               <a:solidFill>
@@ -39735,19 +38641,7 @@
                 <a:cs typeface="Montserrat"/>
                 <a:sym typeface="Montserrat"/>
               </a:rPr>
-              <a:t>Введите </a:t>
-            </a:r>
-            <a:r>
-              <a:rPr lang="ru" sz="1000" dirty="0">
-                <a:solidFill>
-                  <a:srgbClr val="1F497D"/>
-                </a:solidFill>
-                <a:latin typeface="+mj-lt"/>
-                <a:ea typeface="Montserrat"/>
-                <a:cs typeface="Montserrat"/>
-                <a:sym typeface="Montserrat"/>
-              </a:rPr>
-              <a:t>текст</a:t>
+              <a:t>Текст 2</a:t>
             </a:r>
             <a:endParaRPr sz="1000" b="0" i="0" u="none" strike="noStrike" cap="none" dirty="0">
               <a:solidFill>
@@ -39825,19 +38719,7 @@
                 <a:cs typeface="Montserrat"/>
                 <a:sym typeface="Montserrat"/>
               </a:rPr>
-              <a:t>Введите </a:t>
-            </a:r>
-            <a:r>
-              <a:rPr lang="ru" sz="1000" dirty="0">
-                <a:solidFill>
-                  <a:srgbClr val="1F497D"/>
-                </a:solidFill>
-                <a:latin typeface="+mj-lt"/>
-                <a:ea typeface="Montserrat"/>
-                <a:cs typeface="Montserrat"/>
-                <a:sym typeface="Montserrat"/>
-              </a:rPr>
-              <a:t>текст</a:t>
+              <a:t>Текст 3</a:t>
             </a:r>
             <a:endParaRPr sz="1000" b="0" i="0" u="none" strike="noStrike" cap="none" dirty="0">
               <a:solidFill>
@@ -39882,34 +38764,19 @@
           </a:bodyPr>
           <a:lstStyle/>
           <a:p>
-            <a:pPr marL="0" marR="0" lvl="0" indent="0" algn="l" rtl="0">
-              <a:lnSpc>
-                <a:spcPct val="100000"/>
-              </a:lnSpc>
-              <a:spcBef>
-                <a:spcPts val="0"/>
-              </a:spcBef>
-              <a:spcAft>
-                <a:spcPts val="0"/>
-              </a:spcAft>
-              <a:buClr>
-                <a:srgbClr val="000000"/>
-              </a:buClr>
+            <a:pPr lvl="0">
               <a:buSzPts val="1900"/>
-              <a:buFont typeface="Arial"/>
-              <a:buNone/>
             </a:pPr>
             <a:r>
-              <a:rPr lang="ru" sz="2000" b="1" i="0" u="none" strike="noStrike" cap="none" dirty="0">
-                <a:solidFill>
-                  <a:schemeClr val="dk1"/>
-                </a:solidFill>
-                <a:latin typeface="+mj-lt"/>
+              <a:rPr lang="ru" sz="2000" b="1" dirty="0">
+                <a:solidFill>
+                  <a:schemeClr val="dk1"/>
+                </a:solidFill>
                 <a:ea typeface="Montserrat Medium"/>
                 <a:cs typeface="Montserrat Medium"/>
                 <a:sym typeface="Montserrat Medium"/>
               </a:rPr>
-              <a:t>ЗАГОЛОВОК ОСНОВНАЯ МЫСЛЬ</a:t>
+              <a:t>ЗАГОЛОВОК</a:t>
             </a:r>
             <a:endParaRPr sz="2000" b="1" i="0" u="none" strike="noStrike" cap="none" dirty="0">
               <a:solidFill>
@@ -40571,19 +39438,7 @@
                 <a:cs typeface="Montserrat"/>
                 <a:sym typeface="Montserrat"/>
               </a:rPr>
-              <a:t>Введите </a:t>
-            </a:r>
-            <a:r>
-              <a:rPr lang="ru" sz="1000" dirty="0">
-                <a:solidFill>
-                  <a:srgbClr val="1F497D"/>
-                </a:solidFill>
-                <a:latin typeface="+mj-lt"/>
-                <a:ea typeface="Montserrat"/>
-                <a:cs typeface="Montserrat"/>
-                <a:sym typeface="Montserrat"/>
-              </a:rPr>
-              <a:t>текст</a:t>
+              <a:t>Текст 2</a:t>
             </a:r>
             <a:endParaRPr sz="1000" b="0" i="0" u="none" strike="noStrike" cap="none" dirty="0">
               <a:solidFill>
@@ -40814,34 +39669,19 @@
           </a:bodyPr>
           <a:lstStyle/>
           <a:p>
-            <a:pPr marL="0" marR="0" lvl="0" indent="0" algn="l" rtl="0">
-              <a:lnSpc>
-                <a:spcPct val="100000"/>
-              </a:lnSpc>
-              <a:spcBef>
-                <a:spcPts val="0"/>
-              </a:spcBef>
-              <a:spcAft>
-                <a:spcPts val="0"/>
-              </a:spcAft>
-              <a:buClr>
-                <a:srgbClr val="000000"/>
-              </a:buClr>
+            <a:pPr lvl="0">
               <a:buSzPts val="1900"/>
-              <a:buFont typeface="Arial"/>
-              <a:buNone/>
             </a:pPr>
             <a:r>
-              <a:rPr lang="ru" sz="2000" b="1" i="0" u="none" strike="noStrike" cap="none" dirty="0">
-                <a:solidFill>
-                  <a:schemeClr val="dk1"/>
-                </a:solidFill>
-                <a:latin typeface="+mj-lt"/>
+              <a:rPr lang="ru" sz="2000" b="1" dirty="0">
+                <a:solidFill>
+                  <a:schemeClr val="dk1"/>
+                </a:solidFill>
                 <a:ea typeface="Montserrat Medium"/>
                 <a:cs typeface="Montserrat Medium"/>
                 <a:sym typeface="Montserrat Medium"/>
               </a:rPr>
-              <a:t>ЗАГОЛОВОК ОСНОВНАЯ МЫСЛЬ</a:t>
+              <a:t>ЗАГОЛОВОК</a:t>
             </a:r>
             <a:endParaRPr sz="2000" b="1" i="0" u="none" strike="noStrike" cap="none" dirty="0">
               <a:solidFill>
@@ -41013,19 +39853,7 @@
                 <a:cs typeface="Montserrat"/>
                 <a:sym typeface="Montserrat"/>
               </a:rPr>
-              <a:t>Введите </a:t>
-            </a:r>
-            <a:r>
-              <a:rPr lang="ru" sz="1000" dirty="0">
-                <a:solidFill>
-                  <a:srgbClr val="1F497D"/>
-                </a:solidFill>
-                <a:latin typeface="+mj-lt"/>
-                <a:ea typeface="Montserrat"/>
-                <a:cs typeface="Montserrat"/>
-                <a:sym typeface="Montserrat"/>
-              </a:rPr>
-              <a:t>текст</a:t>
+              <a:t>Текст 1</a:t>
             </a:r>
             <a:endParaRPr sz="1000" b="0" i="0" u="none" strike="noStrike" cap="none" dirty="0">
               <a:solidFill>
@@ -41103,19 +39931,7 @@
                 <a:cs typeface="Montserrat"/>
                 <a:sym typeface="Montserrat"/>
               </a:rPr>
-              <a:t>Введите </a:t>
-            </a:r>
-            <a:r>
-              <a:rPr lang="ru" sz="1000" dirty="0">
-                <a:solidFill>
-                  <a:srgbClr val="1F497D"/>
-                </a:solidFill>
-                <a:latin typeface="+mj-lt"/>
-                <a:ea typeface="Montserrat"/>
-                <a:cs typeface="Montserrat"/>
-                <a:sym typeface="Montserrat"/>
-              </a:rPr>
-              <a:t>текст</a:t>
+              <a:t>Текст 3</a:t>
             </a:r>
             <a:endParaRPr sz="1000" b="0" i="0" u="none" strike="noStrike" cap="none" dirty="0">
               <a:solidFill>

</xml_diff>